<commit_message>
sandbox: convert QECA deck into blank template
</commit_message>
<xml_diff>
--- a/sandbox/qubit_external_coupling_analysis/outputs/slides/parameter_response_vv/output/qeca_parameter_response_vv_report.pptx
+++ b/sandbox/qubit_external_coupling_analysis/outputs/slides/parameter_response_vv/output/qeca_parameter_response_vv_report.pptx
@@ -2274,7 +2274,7 @@
                 <a:ea typeface="Avenir Next" pitchFamily="34" charset="-122"/>
                 <a:cs typeface="Avenir Next" pitchFamily="34" charset="-120"/>
               </a:rPr>
-              <a:t>QECA PARAMETER-RESPONSE V&amp;V</a:t>
+              <a:t>REPORT TEMPLATE</a:t>
             </a:r>
             <a:endParaRPr lang="en-US" sz="920" dirty="0"/>
           </a:p>
@@ -2313,24 +2313,7 @@
                 <a:ea typeface="Avenir Next" pitchFamily="34" charset="-122"/>
                 <a:cs typeface="Avenir Next" pitchFamily="34" charset="-120"/>
               </a:rPr>
-              <a:t>Verification deck for</a:t>
-            </a:r>
-            <a:endParaRPr lang="en-US" sz="2700" dirty="0"/>
-          </a:p>
-          <a:p>
-            <a:pPr indent="0" marL="0">
-              <a:buNone/>
-            </a:pPr>
-            <a:r>
-              <a:rPr lang="en-US" sz="2700" b="1" dirty="0">
-                <a:solidFill>
-                  <a:srgbClr val="10233A"/>
-                </a:solidFill>
-                <a:latin typeface="Avenir Next" pitchFamily="34" charset="0"/>
-                <a:ea typeface="Avenir Next" pitchFamily="34" charset="-122"/>
-                <a:cs typeface="Avenir Next" pitchFamily="34" charset="-120"/>
-              </a:rPr>
-              <a:t>parameter-response falsification</a:t>
+              <a:t>[Report title]</a:t>
             </a:r>
             <a:endParaRPr lang="en-US" sz="2700" dirty="0"/>
           </a:p>
@@ -2369,7 +2352,7 @@
                 <a:ea typeface="Avenir Next" pitchFamily="34" charset="-122"/>
                 <a:cs typeface="Avenir Next" pitchFamily="34" charset="-120"/>
               </a:rPr>
-              <a:t>The deck assumes you do not want to line-by-line audit every implementation detail. Instead, you audit each structure and each interface by sweeping the knobs that should expose incorrect behavior first.</a:t>
+              <a:t>[Add subtitle, scope, or one-paragraph framing here.]</a:t>
             </a:r>
             <a:endParaRPr lang="en-US" sz="1140" dirty="0"/>
           </a:p>
@@ -2435,7 +2418,7 @@
                 <a:ea typeface="Avenir Next" pitchFamily="34" charset="-122"/>
                 <a:cs typeface="Avenir Next" pitchFamily="34" charset="-120"/>
               </a:rPr>
-              <a:t>Report Order</a:t>
+              <a:t>[Section list]</a:t>
             </a:r>
             <a:endParaRPr lang="en-US" sz="1090" dirty="0"/>
           </a:p>
@@ -2475,7 +2458,7 @@
                 <a:ea typeface="Avenir Next" pitchFamily="34" charset="-122"/>
                 <a:cs typeface="Avenir Next" pitchFamily="34" charset="-120"/>
               </a:rPr>
-              <a:t>Four structures: parameters and expected response</a:t>
+              <a:t>[Section 1]</a:t>
             </a:r>
             <a:endParaRPr lang="en-US" sz="980" dirty="0"/>
           </a:p>
@@ -2493,7 +2476,7 @@
                 <a:ea typeface="Avenir Next" pitchFamily="34" charset="-122"/>
                 <a:cs typeface="Avenir Next" pitchFamily="34" charset="-120"/>
               </a:rPr>
-              <a:t>Six pairwise interfaces: direct or mediated</a:t>
+              <a:t>[Section 2]</a:t>
             </a:r>
             <a:endParaRPr lang="en-US" sz="980" dirty="0"/>
           </a:p>
@@ -2511,7 +2494,7 @@
                 <a:ea typeface="Avenir Next" pitchFamily="34" charset="-122"/>
                 <a:cs typeface="Avenir Next" pitchFamily="34" charset="-120"/>
               </a:rPr>
-              <a:t>Expected behavior versus actual behavior slot</a:t>
+              <a:t>[Section 3]</a:t>
             </a:r>
             <a:endParaRPr lang="en-US" sz="980" dirty="0"/>
           </a:p>
@@ -2529,7 +2512,7 @@
                 <a:ea typeface="Avenir Next" pitchFamily="34" charset="-122"/>
                 <a:cs typeface="Avenir Next" pitchFamily="34" charset="-120"/>
               </a:rPr>
-              <a:t>End with a repeatable execution checklist</a:t>
+              <a:t>[Section 4]</a:t>
             </a:r>
             <a:endParaRPr lang="en-US" sz="980" dirty="0"/>
           </a:p>
@@ -2568,48 +2551,9 @@
                 <a:ea typeface="Avenir Next" pitchFamily="34" charset="-122"/>
                 <a:cs typeface="Avenir Next" pitchFamily="34" charset="-120"/>
               </a:rPr>
-              <a:t>Core matrix views in this study: reduced Ydm,in(ω), full Y(ω), Z→Y reductions, and readout-branch S21 with vector fitting.</a:t>
+              <a:t>[Optional notes / metadata]</a:t>
             </a:r>
             <a:endParaRPr lang="en-US" sz="950" dirty="0"/>
-          </a:p>
-        </p:txBody>
-      </p:sp>
-      <p:sp>
-        <p:nvSpPr>
-          <p:cNvPr id="13" name="Text 11"/>
-          <p:cNvSpPr/>
-          <p:nvPr/>
-        </p:nvSpPr>
-        <p:spPr>
-          <a:xfrm>
-            <a:off x="749808" y="6473952"/>
-            <a:ext cx="5943600" cy="109728"/>
-          </a:xfrm>
-          <a:prstGeom prst="rect">
-            <a:avLst/>
-          </a:prstGeom>
-          <a:noFill/>
-          <a:ln/>
-        </p:spPr>
-        <p:txBody>
-          <a:bodyPr wrap="square" lIns="0" tIns="0" rIns="0" bIns="0" rtlCol="0" anchor="ctr"/>
-          <a:lstStyle/>
-          <a:p>
-            <a:pPr indent="0" marL="0">
-              <a:buNone/>
-            </a:pPr>
-            <a:r>
-              <a:rPr lang="en-US" sz="870" dirty="0">
-                <a:solidFill>
-                  <a:srgbClr val="667487"/>
-                </a:solidFill>
-                <a:latin typeface="Avenir Next" pitchFamily="34" charset="0"/>
-                <a:ea typeface="Avenir Next" pitchFamily="34" charset="-122"/>
-                <a:cs typeface="Avenir Next" pitchFamily="34" charset="-120"/>
-              </a:rPr>
-              <a:t>Use this as the report front section before presenting any actual sweep results.</a:t>
-            </a:r>
-            <a:endParaRPr lang="en-US" sz="870" dirty="0"/>
           </a:p>
         </p:txBody>
       </p:sp>
@@ -2822,7 +2766,7 @@
                 <a:ea typeface="Avenir Next" pitchFamily="34" charset="-122"/>
                 <a:cs typeface="Avenir Next" pitchFamily="34" charset="-120"/>
               </a:rPr>
-              <a:t>Each pair should be audited by asking whether the parameter-response pattern matches the topology that this model actually contains.</a:t>
+              <a:t>[Add one-line framing for this interface.]</a:t>
             </a:r>
             <a:endParaRPr lang="en-US" sz="1100" dirty="0"/>
           </a:p>
@@ -2993,7 +2937,7 @@
                 <a:ea typeface="Menlo" pitchFamily="34" charset="-122"/>
                 <a:cs typeface="Menlo" pitchFamily="34" charset="-120"/>
               </a:rPr>
-              <a:t>c_rq1_f</a:t>
+              <a:t>[Controlling knob 1]</a:t>
             </a:r>
             <a:endParaRPr lang="en-US" sz="920" dirty="0"/>
           </a:p>
@@ -3010,7 +2954,7 @@
                 <a:ea typeface="Menlo" pitchFamily="34" charset="-122"/>
                 <a:cs typeface="Menlo" pitchFamily="34" charset="-120"/>
               </a:rPr>
-              <a:t>c_rq2_f</a:t>
+              <a:t>[Controlling knob 2]</a:t>
             </a:r>
             <a:endParaRPr lang="en-US" sz="920" dirty="0"/>
           </a:p>
@@ -3027,7 +2971,7 @@
                 <a:ea typeface="Menlo" pitchFamily="34" charset="-122"/>
                 <a:cs typeface="Menlo" pitchFamily="34" charset="-120"/>
               </a:rPr>
-              <a:t>qwr_length_m (alignment context)</a:t>
+              <a:t>[Controlling knob 3]</a:t>
             </a:r>
             <a:endParaRPr lang="en-US" sz="920" dirty="0"/>
           </a:p>
@@ -3132,7 +3076,7 @@
                 <a:ea typeface="Avenir Next" pitchFamily="34" charset="-122"/>
                 <a:cs typeface="Avenir Next" pitchFamily="34" charset="-120"/>
               </a:rPr>
-              <a:t>Use reduced Ydm,in(ω) at the qubit plus S21 context from the readout branch.</a:t>
+              <a:t>[Add primary matrix / observable for this interface.]</a:t>
             </a:r>
             <a:endParaRPr lang="en-US" sz="1010" dirty="0"/>
           </a:p>
@@ -3238,7 +3182,7 @@
                 <a:ea typeface="Avenir Next" pitchFamily="34" charset="-122"/>
                 <a:cs typeface="Avenir Next" pitchFamily="34" charset="-120"/>
               </a:rPr>
-              <a:t>Increasing c_rq should strengthen readout-mediated frequency shift and loss.</a:t>
+              <a:t>[Expected behavior 1]</a:t>
             </a:r>
             <a:endParaRPr lang="en-US" sz="990" dirty="0"/>
           </a:p>
@@ -3256,7 +3200,7 @@
                 <a:ea typeface="Avenir Next" pitchFamily="34" charset="-122"/>
                 <a:cs typeface="Avenir Next" pitchFamily="34" charset="-120"/>
               </a:rPr>
-              <a:t>Tuning the resonator closer to the qubit should increase loading.</a:t>
+              <a:t>[Expected behavior 2]</a:t>
             </a:r>
             <a:endParaRPr lang="en-US" sz="990" dirty="0"/>
           </a:p>
@@ -3274,7 +3218,7 @@
                 <a:ea typeface="Avenir Next" pitchFamily="34" charset="-122"/>
                 <a:cs typeface="Avenir Next" pitchFamily="34" charset="-120"/>
               </a:rPr>
-              <a:t>Setting c_rq1 = c_rq2 = 0 should disconnect the qubit from the entire readout branch.</a:t>
+              <a:t>[Expected behavior 3]</a:t>
             </a:r>
             <a:endParaRPr lang="en-US" sz="990" dirty="0"/>
           </a:p>
@@ -3353,7 +3297,7 @@
                 <a:ea typeface="Avenir Next" pitchFamily="34" charset="-122"/>
                 <a:cs typeface="Avenir Next" pitchFamily="34" charset="-120"/>
               </a:rPr>
-              <a:t>The qubit still feels the readout branch when c_rq is zero.</a:t>
+              <a:t>[Failure signature 1]</a:t>
             </a:r>
             <a:endParaRPr lang="en-US" sz="980" dirty="0"/>
           </a:p>
@@ -3371,7 +3315,7 @@
                 <a:ea typeface="Avenir Next" pitchFamily="34" charset="-122"/>
                 <a:cs typeface="Avenir Next" pitchFamily="34" charset="-120"/>
               </a:rPr>
-              <a:t>Changing qwr length strongly affects the qubit with the interface opened.</a:t>
+              <a:t>[Failure signature 2]</a:t>
             </a:r>
             <a:endParaRPr lang="en-US" sz="980" dirty="0"/>
           </a:p>
@@ -3389,7 +3333,7 @@
                 <a:ea typeface="Avenir Next" pitchFamily="34" charset="-122"/>
                 <a:cs typeface="Avenir Next" pitchFamily="34" charset="-120"/>
               </a:rPr>
-              <a:t>Observed shift and loss move incoherently under the same c_rq sweep.</a:t>
+              <a:t>[Failure signature 3]</a:t>
             </a:r>
             <a:endParaRPr lang="en-US" sz="980" dirty="0"/>
           </a:p>
@@ -3484,7 +3428,7 @@
                 <a:ea typeface="Avenir Next" pitchFamily="34" charset="-122"/>
                 <a:cs typeface="Avenir Next" pitchFamily="34" charset="-120"/>
               </a:rPr>
-              <a:t>Actual behavior / plot slot</a:t>
+              <a:t>[Plot / notes area]</a:t>
             </a:r>
             <a:endParaRPr lang="en-US" sz="1100" dirty="0"/>
           </a:p>
@@ -3523,7 +3467,7 @@
                 <a:ea typeface="Avenir Next" pitchFamily="34" charset="-122"/>
                 <a:cs typeface="Avenir Next" pitchFamily="34" charset="-120"/>
               </a:rPr>
-              <a:t>Insert: c_rq sweep, qwr detuning sweep, and readout-off null check.</a:t>
+              <a:t>Paste plot, table, or notes here.</a:t>
             </a:r>
             <a:endParaRPr lang="en-US" sz="1020" dirty="0"/>
           </a:p>
@@ -3562,7 +3506,7 @@
                 <a:ea typeface="Avenir Next" pitchFamily="34" charset="-122"/>
                 <a:cs typeface="Avenir Next" pitchFamily="34" charset="-120"/>
               </a:rPr>
-              <a:t>Recommended inserts</a:t>
+              <a:t>[Optional checklist]</a:t>
             </a:r>
             <a:endParaRPr lang="en-US" sz="970" dirty="0"/>
           </a:p>
@@ -3602,7 +3546,7 @@
                 <a:ea typeface="Avenir Next" pitchFamily="34" charset="-122"/>
                 <a:cs typeface="Avenir Next" pitchFamily="34" charset="-120"/>
               </a:rPr>
-              <a:t>One sweep plot with a monotonic knob on the x-axis</a:t>
+              <a:t>[Add visual 1]</a:t>
             </a:r>
             <a:endParaRPr lang="en-US" sz="950" dirty="0"/>
           </a:p>
@@ -3620,7 +3564,7 @@
                 <a:ea typeface="Avenir Next" pitchFamily="34" charset="-122"/>
                 <a:cs typeface="Avenir Next" pitchFamily="34" charset="-120"/>
               </a:rPr>
-              <a:t>One null-test or decoupling-limit comparison</a:t>
+              <a:t>[Add visual 2]</a:t>
             </a:r>
             <a:endParaRPr lang="en-US" sz="950" dirty="0"/>
           </a:p>
@@ -3638,48 +3582,9 @@
                 <a:ea typeface="Avenir Next" pitchFamily="34" charset="-122"/>
                 <a:cs typeface="Avenir Next" pitchFamily="34" charset="-120"/>
               </a:rPr>
-              <a:t>One sentence on whether the observed trend matches expectation</a:t>
+              <a:t>[Add short takeaway]</a:t>
             </a:r>
             <a:endParaRPr lang="en-US" sz="950" dirty="0"/>
-          </a:p>
-        </p:txBody>
-      </p:sp>
-      <p:sp>
-        <p:nvSpPr>
-          <p:cNvPr id="26" name="Text 24"/>
-          <p:cNvSpPr/>
-          <p:nvPr/>
-        </p:nvSpPr>
-        <p:spPr>
-          <a:xfrm>
-            <a:off x="749808" y="6473952"/>
-            <a:ext cx="5943600" cy="109728"/>
-          </a:xfrm>
-          <a:prstGeom prst="rect">
-            <a:avLst/>
-          </a:prstGeom>
-          <a:noFill/>
-          <a:ln/>
-        </p:spPr>
-        <p:txBody>
-          <a:bodyPr wrap="square" lIns="0" tIns="0" rIns="0" bIns="0" rtlCol="0" anchor="ctr"/>
-          <a:lstStyle/>
-          <a:p>
-            <a:pPr indent="0" marL="0">
-              <a:buNone/>
-            </a:pPr>
-            <a:r>
-              <a:rPr lang="en-US" sz="870" dirty="0">
-                <a:solidFill>
-                  <a:srgbClr val="667487"/>
-                </a:solidFill>
-                <a:latin typeface="Avenir Next" pitchFamily="34" charset="0"/>
-                <a:ea typeface="Avenir Next" pitchFamily="34" charset="-122"/>
-                <a:cs typeface="Avenir Next" pitchFamily="34" charset="-120"/>
-              </a:rPr>
-              <a:t>For mediated pairs, path-breaking null tests matter more than large parameter sweeps.</a:t>
-            </a:r>
-            <a:endParaRPr lang="en-US" sz="870" dirty="0"/>
           </a:p>
         </p:txBody>
       </p:sp>
@@ -3892,7 +3797,7 @@
                 <a:ea typeface="Avenir Next" pitchFamily="34" charset="-122"/>
                 <a:cs typeface="Avenir Next" pitchFamily="34" charset="-120"/>
               </a:rPr>
-              <a:t>Each pair should be audited by asking whether the parameter-response pattern matches the topology that this model actually contains.</a:t>
+              <a:t>[Add one-line framing for this interface.]</a:t>
             </a:r>
             <a:endParaRPr lang="en-US" sz="1100" dirty="0"/>
           </a:p>
@@ -4063,7 +3968,7 @@
                 <a:ea typeface="Menlo" pitchFamily="34" charset="-122"/>
                 <a:cs typeface="Menlo" pitchFamily="34" charset="-120"/>
               </a:rPr>
-              <a:t>coupled_window_length_m</a:t>
+              <a:t>[Controlling knob 1]</a:t>
             </a:r>
             <a:endParaRPr lang="en-US" sz="920" dirty="0"/>
           </a:p>
@@ -4080,7 +3985,7 @@
                 <a:ea typeface="Menlo" pitchFamily="34" charset="-122"/>
                 <a:cs typeface="Menlo" pitchFamily="34" charset="-120"/>
               </a:rPr>
-              <a:t>coupled_window_input_mode</a:t>
+              <a:t>[Controlling knob 2]</a:t>
             </a:r>
             <a:endParaRPr lang="en-US" sz="920" dirty="0"/>
           </a:p>
@@ -4097,24 +4002,7 @@
                 <a:ea typeface="Menlo" pitchFamily="34" charset="-122"/>
                 <a:cs typeface="Menlo" pitchFamily="34" charset="-120"/>
               </a:rPr>
-              <a:t>q2d_* or modal even/odd parameters</a:t>
-            </a:r>
-            <a:endParaRPr lang="en-US" sz="920" dirty="0"/>
-          </a:p>
-          <a:p>
-            <a:pPr indent="0" marL="0">
-              <a:buNone/>
-            </a:pPr>
-            <a:r>
-              <a:rPr lang="en-US" sz="920" dirty="0">
-                <a:solidFill>
-                  <a:srgbClr val="667487"/>
-                </a:solidFill>
-                <a:latin typeface="Menlo" pitchFamily="34" charset="0"/>
-                <a:ea typeface="Menlo" pitchFamily="34" charset="-122"/>
-                <a:cs typeface="Menlo" pitchFamily="34" charset="-120"/>
-              </a:rPr>
-              <a:t>pf_window_start_m, qwr_window_start_m</a:t>
+              <a:t>[Controlling knob 3]</a:t>
             </a:r>
             <a:endParaRPr lang="en-US" sz="920" dirty="0"/>
           </a:p>
@@ -4219,7 +4107,7 @@
                 <a:ea typeface="Avenir Next" pitchFamily="34" charset="-122"/>
                 <a:cs typeface="Avenir Next" pitchFamily="34" charset="-120"/>
               </a:rPr>
-              <a:t>Use raw S21, fitted S21 model, and extracted resonances from the readout branch.</a:t>
+              <a:t>[Add primary matrix / observable for this interface.]</a:t>
             </a:r>
             <a:endParaRPr lang="en-US" sz="1010" dirty="0"/>
           </a:p>
@@ -4325,7 +4213,7 @@
                 <a:ea typeface="Avenir Next" pitchFamily="34" charset="-122"/>
                 <a:cs typeface="Avenir Next" pitchFamily="34" charset="-120"/>
               </a:rPr>
-              <a:t>Longer or stronger coupled-window interaction should increase hybridization.</a:t>
+              <a:t>[Expected behavior 1]</a:t>
             </a:r>
             <a:endParaRPr lang="en-US" sz="990" dirty="0"/>
           </a:p>
@@ -4343,7 +4231,7 @@
                 <a:ea typeface="Avenir Next" pitchFamily="34" charset="-122"/>
                 <a:cs typeface="Avenir Next" pitchFamily="34" charset="-120"/>
               </a:rPr>
-              <a:t>Window length → 0 or mutual terms → 0 should decouple the resonator from the line.</a:t>
+              <a:t>[Expected behavior 2]</a:t>
             </a:r>
             <a:endParaRPr lang="en-US" sz="990" dirty="0"/>
           </a:p>
@@ -4361,7 +4249,7 @@
                 <a:ea typeface="Avenir Next" pitchFamily="34" charset="-122"/>
                 <a:cs typeface="Avenir Next" pitchFamily="34" charset="-120"/>
               </a:rPr>
-              <a:t>Modal and q2d parameterizations should agree qualitatively on trend direction.</a:t>
+              <a:t>[Expected behavior 3]</a:t>
             </a:r>
             <a:endParaRPr lang="en-US" sz="990" dirty="0"/>
           </a:p>
@@ -4440,7 +4328,7 @@
                 <a:ea typeface="Avenir Next" pitchFamily="34" charset="-122"/>
                 <a:cs typeface="Avenir Next" pitchFamily="34" charset="-120"/>
               </a:rPr>
-              <a:t>The resonator feature does not respond to window strength at all.</a:t>
+              <a:t>[Failure signature 1]</a:t>
             </a:r>
             <a:endParaRPr lang="en-US" sz="980" dirty="0"/>
           </a:p>
@@ -4458,7 +4346,7 @@
                 <a:ea typeface="Avenir Next" pitchFamily="34" charset="-122"/>
                 <a:cs typeface="Avenir Next" pitchFamily="34" charset="-120"/>
               </a:rPr>
-              <a:t>The line still shows strong resonator loading with the window effectively off.</a:t>
+              <a:t>[Failure signature 2]</a:t>
             </a:r>
             <a:endParaRPr lang="en-US" sz="980" dirty="0"/>
           </a:p>
@@ -4476,7 +4364,7 @@
                 <a:ea typeface="Avenir Next" pitchFamily="34" charset="-122"/>
                 <a:cs typeface="Avenir Next" pitchFamily="34" charset="-120"/>
               </a:rPr>
-              <a:t>q2d and modal modes disagree on basic trend direction.</a:t>
+              <a:t>[Failure signature 3]</a:t>
             </a:r>
             <a:endParaRPr lang="en-US" sz="980" dirty="0"/>
           </a:p>
@@ -4571,7 +4459,7 @@
                 <a:ea typeface="Avenir Next" pitchFamily="34" charset="-122"/>
                 <a:cs typeface="Avenir Next" pitchFamily="34" charset="-120"/>
               </a:rPr>
-              <a:t>Actual behavior / plot slot</a:t>
+              <a:t>[Plot / notes area]</a:t>
             </a:r>
             <a:endParaRPr lang="en-US" sz="1100" dirty="0"/>
           </a:p>
@@ -4610,7 +4498,7 @@
                 <a:ea typeface="Avenir Next" pitchFamily="34" charset="-122"/>
                 <a:cs typeface="Avenir Next" pitchFamily="34" charset="-120"/>
               </a:rPr>
-              <a:t>Insert: coupled-window length sweep, modal-vs-q2d comparison, and one decoupling limit plot.</a:t>
+              <a:t>Paste plot, table, or notes here.</a:t>
             </a:r>
             <a:endParaRPr lang="en-US" sz="1020" dirty="0"/>
           </a:p>
@@ -4649,7 +4537,7 @@
                 <a:ea typeface="Avenir Next" pitchFamily="34" charset="-122"/>
                 <a:cs typeface="Avenir Next" pitchFamily="34" charset="-120"/>
               </a:rPr>
-              <a:t>Recommended inserts</a:t>
+              <a:t>[Optional checklist]</a:t>
             </a:r>
             <a:endParaRPr lang="en-US" sz="970" dirty="0"/>
           </a:p>
@@ -4689,7 +4577,7 @@
                 <a:ea typeface="Avenir Next" pitchFamily="34" charset="-122"/>
                 <a:cs typeface="Avenir Next" pitchFamily="34" charset="-120"/>
               </a:rPr>
-              <a:t>One sweep plot with a monotonic knob on the x-axis</a:t>
+              <a:t>[Add visual 1]</a:t>
             </a:r>
             <a:endParaRPr lang="en-US" sz="950" dirty="0"/>
           </a:p>
@@ -4707,7 +4595,7 @@
                 <a:ea typeface="Avenir Next" pitchFamily="34" charset="-122"/>
                 <a:cs typeface="Avenir Next" pitchFamily="34" charset="-120"/>
               </a:rPr>
-              <a:t>One null-test or decoupling-limit comparison</a:t>
+              <a:t>[Add visual 2]</a:t>
             </a:r>
             <a:endParaRPr lang="en-US" sz="950" dirty="0"/>
           </a:p>
@@ -4725,48 +4613,9 @@
                 <a:ea typeface="Avenir Next" pitchFamily="34" charset="-122"/>
                 <a:cs typeface="Avenir Next" pitchFamily="34" charset="-120"/>
               </a:rPr>
-              <a:t>One sentence on whether the observed trend matches expectation</a:t>
+              <a:t>[Add short takeaway]</a:t>
             </a:r>
             <a:endParaRPr lang="en-US" sz="950" dirty="0"/>
-          </a:p>
-        </p:txBody>
-      </p:sp>
-      <p:sp>
-        <p:nvSpPr>
-          <p:cNvPr id="26" name="Text 24"/>
-          <p:cNvSpPr/>
-          <p:nvPr/>
-        </p:nvSpPr>
-        <p:spPr>
-          <a:xfrm>
-            <a:off x="749808" y="6473952"/>
-            <a:ext cx="5943600" cy="109728"/>
-          </a:xfrm>
-          <a:prstGeom prst="rect">
-            <a:avLst/>
-          </a:prstGeom>
-          <a:noFill/>
-          <a:ln/>
-        </p:spPr>
-        <p:txBody>
-          <a:bodyPr wrap="square" lIns="0" tIns="0" rIns="0" bIns="0" rtlCol="0" anchor="ctr"/>
-          <a:lstStyle/>
-          <a:p>
-            <a:pPr indent="0" marL="0">
-              <a:buNone/>
-            </a:pPr>
-            <a:r>
-              <a:rPr lang="en-US" sz="870" dirty="0">
-                <a:solidFill>
-                  <a:srgbClr val="667487"/>
-                </a:solidFill>
-                <a:latin typeface="Avenir Next" pitchFamily="34" charset="0"/>
-                <a:ea typeface="Avenir Next" pitchFamily="34" charset="-122"/>
-                <a:cs typeface="Avenir Next" pitchFamily="34" charset="-120"/>
-              </a:rPr>
-              <a:t>For mediated pairs, path-breaking null tests matter more than large parameter sweeps.</a:t>
-            </a:r>
-            <a:endParaRPr lang="en-US" sz="870" dirty="0"/>
           </a:p>
         </p:txBody>
       </p:sp>
@@ -4979,7 +4828,7 @@
                 <a:ea typeface="Avenir Next" pitchFamily="34" charset="-122"/>
                 <a:cs typeface="Avenir Next" pitchFamily="34" charset="-120"/>
               </a:rPr>
-              <a:t>Each pair should be audited by asking whether the parameter-response pattern matches the topology that this model actually contains.</a:t>
+              <a:t>[Add one-line framing for this interface.]</a:t>
             </a:r>
             <a:endParaRPr lang="en-US" sz="1100" dirty="0"/>
           </a:p>
@@ -5150,7 +4999,7 @@
                 <a:ea typeface="Menlo" pitchFamily="34" charset="-122"/>
                 <a:cs typeface="Menlo" pitchFamily="34" charset="-120"/>
               </a:rPr>
-              <a:t>No direct knob in this model</a:t>
+              <a:t>[Controlling knob 1]</a:t>
             </a:r>
             <a:endParaRPr lang="en-US" sz="920" dirty="0"/>
           </a:p>
@@ -5167,7 +5016,24 @@
                 <a:ea typeface="Menlo" pitchFamily="34" charset="-122"/>
                 <a:cs typeface="Menlo" pitchFamily="34" charset="-120"/>
               </a:rPr>
-              <a:t>Path toggles: c_rq*, coupled_window_length_m, PF branch lengths</a:t>
+              <a:t>[Controlling knob 2]</a:t>
+            </a:r>
+            <a:endParaRPr lang="en-US" sz="920" dirty="0"/>
+          </a:p>
+          <a:p>
+            <a:pPr indent="0" marL="0">
+              <a:buNone/>
+            </a:pPr>
+            <a:r>
+              <a:rPr lang="en-US" sz="920" dirty="0">
+                <a:solidFill>
+                  <a:srgbClr val="667487"/>
+                </a:solidFill>
+                <a:latin typeface="Menlo" pitchFamily="34" charset="0"/>
+                <a:ea typeface="Menlo" pitchFamily="34" charset="-122"/>
+                <a:cs typeface="Menlo" pitchFamily="34" charset="-120"/>
+              </a:rPr>
+              <a:t>[Controlling knob 3]</a:t>
             </a:r>
             <a:endParaRPr lang="en-US" sz="920" dirty="0"/>
           </a:p>
@@ -5272,7 +5138,7 @@
                 <a:ea typeface="Avenir Next" pitchFamily="34" charset="-122"/>
                 <a:cs typeface="Avenir Next" pitchFamily="34" charset="-120"/>
               </a:rPr>
-              <a:t>Use reduced Ydm,in(ω) for the qubit and S21 for the readout branch as a path-consistency check.</a:t>
+              <a:t>[Add primary matrix / observable for this interface.]</a:t>
             </a:r>
             <a:endParaRPr lang="en-US" sz="1010" dirty="0"/>
           </a:p>
@@ -5378,7 +5244,7 @@
                 <a:ea typeface="Avenir Next" pitchFamily="34" charset="-122"/>
                 <a:cs typeface="Avenir Next" pitchFamily="34" charset="-120"/>
               </a:rPr>
-              <a:t>This effect must disappear if either the qubit↔resonator or resonator↔line interface is opened.</a:t>
+              <a:t>[Expected behavior 1]</a:t>
             </a:r>
             <a:endParaRPr lang="en-US" sz="990" dirty="0"/>
           </a:p>
@@ -5396,7 +5262,7 @@
                 <a:ea typeface="Avenir Next" pitchFamily="34" charset="-122"/>
                 <a:cs typeface="Avenir Next" pitchFamily="34" charset="-120"/>
               </a:rPr>
-              <a:t>Changing PF geometry with c_rq = 0 should not move the qubit result.</a:t>
+              <a:t>[Expected behavior 2]</a:t>
             </a:r>
             <a:endParaRPr lang="en-US" sz="990" dirty="0"/>
           </a:p>
@@ -5414,7 +5280,7 @@
                 <a:ea typeface="Avenir Next" pitchFamily="34" charset="-122"/>
                 <a:cs typeface="Avenir Next" pitchFamily="34" charset="-120"/>
               </a:rPr>
-              <a:t>The effect should look path-mediated, not like a brand-new direct capacitor.</a:t>
+              <a:t>[Expected behavior 3]</a:t>
             </a:r>
             <a:endParaRPr lang="en-US" sz="990" dirty="0"/>
           </a:p>
@@ -5493,7 +5359,7 @@
                 <a:ea typeface="Avenir Next" pitchFamily="34" charset="-122"/>
                 <a:cs typeface="Avenir Next" pitchFamily="34" charset="-120"/>
               </a:rPr>
-              <a:t>PF changes move the qubit even with c_rq opened.</a:t>
+              <a:t>[Failure signature 1]</a:t>
             </a:r>
             <a:endParaRPr lang="en-US" sz="980" dirty="0"/>
           </a:p>
@@ -5511,7 +5377,7 @@
                 <a:ea typeface="Avenir Next" pitchFamily="34" charset="-122"/>
                 <a:cs typeface="Avenir Next" pitchFamily="34" charset="-120"/>
               </a:rPr>
-              <a:t>The qubit responds as if there were a direct line coupling that is absent from the netlist.</a:t>
+              <a:t>[Failure signature 2]</a:t>
             </a:r>
             <a:endParaRPr lang="en-US" sz="980" dirty="0"/>
           </a:p>
@@ -5529,7 +5395,7 @@
                 <a:ea typeface="Avenir Next" pitchFamily="34" charset="-122"/>
                 <a:cs typeface="Avenir Next" pitchFamily="34" charset="-120"/>
               </a:rPr>
-              <a:t>Path-breaking toggles do not suppress the effect.</a:t>
+              <a:t>[Failure signature 3]</a:t>
             </a:r>
             <a:endParaRPr lang="en-US" sz="980" dirty="0"/>
           </a:p>
@@ -5624,7 +5490,7 @@
                 <a:ea typeface="Avenir Next" pitchFamily="34" charset="-122"/>
                 <a:cs typeface="Avenir Next" pitchFamily="34" charset="-120"/>
               </a:rPr>
-              <a:t>Actual behavior / plot slot</a:t>
+              <a:t>[Plot / notes area]</a:t>
             </a:r>
             <a:endParaRPr lang="en-US" sz="1100" dirty="0"/>
           </a:p>
@@ -5663,7 +5529,7 @@
                 <a:ea typeface="Avenir Next" pitchFamily="34" charset="-122"/>
                 <a:cs typeface="Avenir Next" pitchFamily="34" charset="-120"/>
               </a:rPr>
-              <a:t>Insert: PF sweep with c_rq on/off, plus one path-break comparison panel.</a:t>
+              <a:t>Paste plot, table, or notes here.</a:t>
             </a:r>
             <a:endParaRPr lang="en-US" sz="1020" dirty="0"/>
           </a:p>
@@ -5702,7 +5568,7 @@
                 <a:ea typeface="Avenir Next" pitchFamily="34" charset="-122"/>
                 <a:cs typeface="Avenir Next" pitchFamily="34" charset="-120"/>
               </a:rPr>
-              <a:t>Recommended inserts</a:t>
+              <a:t>[Optional checklist]</a:t>
             </a:r>
             <a:endParaRPr lang="en-US" sz="970" dirty="0"/>
           </a:p>
@@ -5742,7 +5608,7 @@
                 <a:ea typeface="Avenir Next" pitchFamily="34" charset="-122"/>
                 <a:cs typeface="Avenir Next" pitchFamily="34" charset="-120"/>
               </a:rPr>
-              <a:t>One sweep plot with a monotonic knob on the x-axis</a:t>
+              <a:t>[Add visual 1]</a:t>
             </a:r>
             <a:endParaRPr lang="en-US" sz="950" dirty="0"/>
           </a:p>
@@ -5760,7 +5626,7 @@
                 <a:ea typeface="Avenir Next" pitchFamily="34" charset="-122"/>
                 <a:cs typeface="Avenir Next" pitchFamily="34" charset="-120"/>
               </a:rPr>
-              <a:t>One null-test or decoupling-limit comparison</a:t>
+              <a:t>[Add visual 2]</a:t>
             </a:r>
             <a:endParaRPr lang="en-US" sz="950" dirty="0"/>
           </a:p>
@@ -5778,48 +5644,9 @@
                 <a:ea typeface="Avenir Next" pitchFamily="34" charset="-122"/>
                 <a:cs typeface="Avenir Next" pitchFamily="34" charset="-120"/>
               </a:rPr>
-              <a:t>One sentence on whether the observed trend matches expectation</a:t>
+              <a:t>[Add short takeaway]</a:t>
             </a:r>
             <a:endParaRPr lang="en-US" sz="950" dirty="0"/>
-          </a:p>
-        </p:txBody>
-      </p:sp>
-      <p:sp>
-        <p:nvSpPr>
-          <p:cNvPr id="26" name="Text 24"/>
-          <p:cNvSpPr/>
-          <p:nvPr/>
-        </p:nvSpPr>
-        <p:spPr>
-          <a:xfrm>
-            <a:off x="749808" y="6473952"/>
-            <a:ext cx="5943600" cy="109728"/>
-          </a:xfrm>
-          <a:prstGeom prst="rect">
-            <a:avLst/>
-          </a:prstGeom>
-          <a:noFill/>
-          <a:ln/>
-        </p:spPr>
-        <p:txBody>
-          <a:bodyPr wrap="square" lIns="0" tIns="0" rIns="0" bIns="0" rtlCol="0" anchor="ctr"/>
-          <a:lstStyle/>
-          <a:p>
-            <a:pPr indent="0" marL="0">
-              <a:buNone/>
-            </a:pPr>
-            <a:r>
-              <a:rPr lang="en-US" sz="870" dirty="0">
-                <a:solidFill>
-                  <a:srgbClr val="667487"/>
-                </a:solidFill>
-                <a:latin typeface="Avenir Next" pitchFamily="34" charset="0"/>
-                <a:ea typeface="Avenir Next" pitchFamily="34" charset="-122"/>
-                <a:cs typeface="Avenir Next" pitchFamily="34" charset="-120"/>
-              </a:rPr>
-              <a:t>For mediated pairs, path-breaking null tests matter more than large parameter sweeps.</a:t>
-            </a:r>
-            <a:endParaRPr lang="en-US" sz="870" dirty="0"/>
           </a:p>
         </p:txBody>
       </p:sp>
@@ -6032,7 +5859,7 @@
                 <a:ea typeface="Avenir Next" pitchFamily="34" charset="-122"/>
                 <a:cs typeface="Avenir Next" pitchFamily="34" charset="-120"/>
               </a:rPr>
-              <a:t>Each pair should be audited by asking whether the parameter-response pattern matches the topology that this model actually contains.</a:t>
+              <a:t>[Add one-line framing for this interface.]</a:t>
             </a:r>
             <a:endParaRPr lang="en-US" sz="1100" dirty="0"/>
           </a:p>
@@ -6203,7 +6030,7 @@
                 <a:ea typeface="Menlo" pitchFamily="34" charset="-122"/>
                 <a:cs typeface="Menlo" pitchFamily="34" charset="-120"/>
               </a:rPr>
-              <a:t>No direct knob in this model</a:t>
+              <a:t>[Controlling knob 1]</a:t>
             </a:r>
             <a:endParaRPr lang="en-US" sz="920" dirty="0"/>
           </a:p>
@@ -6220,7 +6047,24 @@
                 <a:ea typeface="Menlo" pitchFamily="34" charset="-122"/>
                 <a:cs typeface="Menlo" pitchFamily="34" charset="-120"/>
               </a:rPr>
-              <a:t>Path toggles: c_rq*, c_xy*</a:t>
+              <a:t>[Controlling knob 2]</a:t>
+            </a:r>
+            <a:endParaRPr lang="en-US" sz="920" dirty="0"/>
+          </a:p>
+          <a:p>
+            <a:pPr indent="0" marL="0">
+              <a:buNone/>
+            </a:pPr>
+            <a:r>
+              <a:rPr lang="en-US" sz="920" dirty="0">
+                <a:solidFill>
+                  <a:srgbClr val="667487"/>
+                </a:solidFill>
+                <a:latin typeface="Menlo" pitchFamily="34" charset="0"/>
+                <a:ea typeface="Menlo" pitchFamily="34" charset="-122"/>
+                <a:cs typeface="Menlo" pitchFamily="34" charset="-120"/>
+              </a:rPr>
+              <a:t>[Controlling knob 3]</a:t>
             </a:r>
             <a:endParaRPr lang="en-US" sz="920" dirty="0"/>
           </a:p>
@@ -6325,7 +6169,7 @@
                 <a:ea typeface="Avenir Next" pitchFamily="34" charset="-122"/>
                 <a:cs typeface="Avenir Next" pitchFamily="34" charset="-120"/>
               </a:rPr>
-              <a:t>Use Ydm,in(ω) and selected full-matrix traces only as a mediated-effect null test.</a:t>
+              <a:t>[Add primary matrix / observable for this interface.]</a:t>
             </a:r>
             <a:endParaRPr lang="en-US" sz="1010" dirty="0"/>
           </a:p>
@@ -6431,7 +6275,7 @@
                 <a:ea typeface="Avenir Next" pitchFamily="34" charset="-122"/>
                 <a:cs typeface="Avenir Next" pitchFamily="34" charset="-120"/>
               </a:rPr>
-              <a:t>This interaction should exist only through the shared qubit network.</a:t>
+              <a:t>[Expected behavior 1]</a:t>
             </a:r>
             <a:endParaRPr lang="en-US" sz="990" dirty="0"/>
           </a:p>
@@ -6449,7 +6293,7 @@
                 <a:ea typeface="Avenir Next" pitchFamily="34" charset="-122"/>
                 <a:cs typeface="Avenir Next" pitchFamily="34" charset="-120"/>
               </a:rPr>
-              <a:t>Zeroing either c_rq or c_xy should kill the path.</a:t>
+              <a:t>[Expected behavior 2]</a:t>
             </a:r>
             <a:endParaRPr lang="en-US" sz="990" dirty="0"/>
           </a:p>
@@ -6467,7 +6311,7 @@
                 <a:ea typeface="Avenir Next" pitchFamily="34" charset="-122"/>
                 <a:cs typeface="Avenir Next" pitchFamily="34" charset="-120"/>
               </a:rPr>
-              <a:t>Any residual feature should be small and systematic, not dominant.</a:t>
+              <a:t>[Expected behavior 3]</a:t>
             </a:r>
             <a:endParaRPr lang="en-US" sz="990" dirty="0"/>
           </a:p>
@@ -6546,7 +6390,7 @@
                 <a:ea typeface="Avenir Next" pitchFamily="34" charset="-122"/>
                 <a:cs typeface="Avenir Next" pitchFamily="34" charset="-120"/>
               </a:rPr>
-              <a:t>A strong RR↔XY effect remains after zeroing one side of the path.</a:t>
+              <a:t>[Failure signature 1]</a:t>
             </a:r>
             <a:endParaRPr lang="en-US" sz="980" dirty="0"/>
           </a:p>
@@ -6564,7 +6408,7 @@
                 <a:ea typeface="Avenir Next" pitchFamily="34" charset="-122"/>
                 <a:cs typeface="Avenir Next" pitchFamily="34" charset="-120"/>
               </a:rPr>
-              <a:t>A new standalone feature appears that cannot be routed through the qubit.</a:t>
+              <a:t>[Failure signature 2]</a:t>
             </a:r>
             <a:endParaRPr lang="en-US" sz="980" dirty="0"/>
           </a:p>
@@ -6582,7 +6426,7 @@
                 <a:ea typeface="Avenir Next" pitchFamily="34" charset="-122"/>
                 <a:cs typeface="Avenir Next" pitchFamily="34" charset="-120"/>
               </a:rPr>
-              <a:t>Trend magnitude is first-order when the topology only allows higher-order mediation.</a:t>
+              <a:t>[Failure signature 3]</a:t>
             </a:r>
             <a:endParaRPr lang="en-US" sz="980" dirty="0"/>
           </a:p>
@@ -6677,7 +6521,7 @@
                 <a:ea typeface="Avenir Next" pitchFamily="34" charset="-122"/>
                 <a:cs typeface="Avenir Next" pitchFamily="34" charset="-120"/>
               </a:rPr>
-              <a:t>Actual behavior / plot slot</a:t>
+              <a:t>[Plot / notes area]</a:t>
             </a:r>
             <a:endParaRPr lang="en-US" sz="1100" dirty="0"/>
           </a:p>
@@ -6716,7 +6560,7 @@
                 <a:ea typeface="Avenir Next" pitchFamily="34" charset="-122"/>
                 <a:cs typeface="Avenir Next" pitchFamily="34" charset="-120"/>
               </a:rPr>
-              <a:t>Insert: c_xy / c_rq path-break matrix and one residual-effect summary.</a:t>
+              <a:t>Paste plot, table, or notes here.</a:t>
             </a:r>
             <a:endParaRPr lang="en-US" sz="1020" dirty="0"/>
           </a:p>
@@ -6755,7 +6599,7 @@
                 <a:ea typeface="Avenir Next" pitchFamily="34" charset="-122"/>
                 <a:cs typeface="Avenir Next" pitchFamily="34" charset="-120"/>
               </a:rPr>
-              <a:t>Recommended inserts</a:t>
+              <a:t>[Optional checklist]</a:t>
             </a:r>
             <a:endParaRPr lang="en-US" sz="970" dirty="0"/>
           </a:p>
@@ -6795,7 +6639,7 @@
                 <a:ea typeface="Avenir Next" pitchFamily="34" charset="-122"/>
                 <a:cs typeface="Avenir Next" pitchFamily="34" charset="-120"/>
               </a:rPr>
-              <a:t>One sweep plot with a monotonic knob on the x-axis</a:t>
+              <a:t>[Add visual 1]</a:t>
             </a:r>
             <a:endParaRPr lang="en-US" sz="950" dirty="0"/>
           </a:p>
@@ -6813,7 +6657,7 @@
                 <a:ea typeface="Avenir Next" pitchFamily="34" charset="-122"/>
                 <a:cs typeface="Avenir Next" pitchFamily="34" charset="-120"/>
               </a:rPr>
-              <a:t>One null-test or decoupling-limit comparison</a:t>
+              <a:t>[Add visual 2]</a:t>
             </a:r>
             <a:endParaRPr lang="en-US" sz="950" dirty="0"/>
           </a:p>
@@ -6831,48 +6675,9 @@
                 <a:ea typeface="Avenir Next" pitchFamily="34" charset="-122"/>
                 <a:cs typeface="Avenir Next" pitchFamily="34" charset="-120"/>
               </a:rPr>
-              <a:t>One sentence on whether the observed trend matches expectation</a:t>
+              <a:t>[Add short takeaway]</a:t>
             </a:r>
             <a:endParaRPr lang="en-US" sz="950" dirty="0"/>
-          </a:p>
-        </p:txBody>
-      </p:sp>
-      <p:sp>
-        <p:nvSpPr>
-          <p:cNvPr id="26" name="Text 24"/>
-          <p:cNvSpPr/>
-          <p:nvPr/>
-        </p:nvSpPr>
-        <p:spPr>
-          <a:xfrm>
-            <a:off x="749808" y="6473952"/>
-            <a:ext cx="5943600" cy="109728"/>
-          </a:xfrm>
-          <a:prstGeom prst="rect">
-            <a:avLst/>
-          </a:prstGeom>
-          <a:noFill/>
-          <a:ln/>
-        </p:spPr>
-        <p:txBody>
-          <a:bodyPr wrap="square" lIns="0" tIns="0" rIns="0" bIns="0" rtlCol="0" anchor="ctr"/>
-          <a:lstStyle/>
-          <a:p>
-            <a:pPr indent="0" marL="0">
-              <a:buNone/>
-            </a:pPr>
-            <a:r>
-              <a:rPr lang="en-US" sz="870" dirty="0">
-                <a:solidFill>
-                  <a:srgbClr val="667487"/>
-                </a:solidFill>
-                <a:latin typeface="Avenir Next" pitchFamily="34" charset="0"/>
-                <a:ea typeface="Avenir Next" pitchFamily="34" charset="-122"/>
-                <a:cs typeface="Avenir Next" pitchFamily="34" charset="-120"/>
-              </a:rPr>
-              <a:t>For mediated pairs, path-breaking null tests matter more than large parameter sweeps.</a:t>
-            </a:r>
-            <a:endParaRPr lang="en-US" sz="870" dirty="0"/>
           </a:p>
         </p:txBody>
       </p:sp>
@@ -7085,7 +6890,7 @@
                 <a:ea typeface="Avenir Next" pitchFamily="34" charset="-122"/>
                 <a:cs typeface="Avenir Next" pitchFamily="34" charset="-120"/>
               </a:rPr>
-              <a:t>Each pair should be audited by asking whether the parameter-response pattern matches the topology that this model actually contains.</a:t>
+              <a:t>[Add one-line framing for this interface.]</a:t>
             </a:r>
             <a:endParaRPr lang="en-US" sz="1100" dirty="0"/>
           </a:p>
@@ -7256,7 +7061,7 @@
                 <a:ea typeface="Menlo" pitchFamily="34" charset="-122"/>
                 <a:cs typeface="Menlo" pitchFamily="34" charset="-120"/>
               </a:rPr>
-              <a:t>No direct knob in this model</a:t>
+              <a:t>[Controlling knob 1]</a:t>
             </a:r>
             <a:endParaRPr lang="en-US" sz="920" dirty="0"/>
           </a:p>
@@ -7273,7 +7078,24 @@
                 <a:ea typeface="Menlo" pitchFamily="34" charset="-122"/>
                 <a:cs typeface="Menlo" pitchFamily="34" charset="-120"/>
               </a:rPr>
-              <a:t>Path toggles: c_xy*, c_rq*, coupled_window_length_m</a:t>
+              <a:t>[Controlling knob 2]</a:t>
+            </a:r>
+            <a:endParaRPr lang="en-US" sz="920" dirty="0"/>
+          </a:p>
+          <a:p>
+            <a:pPr indent="0" marL="0">
+              <a:buNone/>
+            </a:pPr>
+            <a:r>
+              <a:rPr lang="en-US" sz="920" dirty="0">
+                <a:solidFill>
+                  <a:srgbClr val="667487"/>
+                </a:solidFill>
+                <a:latin typeface="Menlo" pitchFamily="34" charset="0"/>
+                <a:ea typeface="Menlo" pitchFamily="34" charset="-122"/>
+                <a:cs typeface="Menlo" pitchFamily="34" charset="-120"/>
+              </a:rPr>
+              <a:t>[Controlling knob 3]</a:t>
             </a:r>
             <a:endParaRPr lang="en-US" sz="920" dirty="0"/>
           </a:p>
@@ -7378,7 +7200,7 @@
                 <a:ea typeface="Avenir Next" pitchFamily="34" charset="-122"/>
                 <a:cs typeface="Avenir Next" pitchFamily="34" charset="-120"/>
               </a:rPr>
-              <a:t>Use Ydm,in(ω) and branch S21 only as a mediated consistency check.</a:t>
+              <a:t>[Add primary matrix / observable for this interface.]</a:t>
             </a:r>
             <a:endParaRPr lang="en-US" sz="1010" dirty="0"/>
           </a:p>
@@ -7484,7 +7306,7 @@
                 <a:ea typeface="Avenir Next" pitchFamily="34" charset="-122"/>
                 <a:cs typeface="Avenir Next" pitchFamily="34" charset="-120"/>
               </a:rPr>
-              <a:t>This is a second-order path through the qubit and resonator network.</a:t>
+              <a:t>[Expected behavior 1]</a:t>
             </a:r>
             <a:endParaRPr lang="en-US" sz="990" dirty="0"/>
           </a:p>
@@ -7502,7 +7324,7 @@
                 <a:ea typeface="Avenir Next" pitchFamily="34" charset="-122"/>
                 <a:cs typeface="Avenir Next" pitchFamily="34" charset="-120"/>
               </a:rPr>
-              <a:t>Zeroing c_xy or c_rq should collapse the interaction.</a:t>
+              <a:t>[Expected behavior 2]</a:t>
             </a:r>
             <a:endParaRPr lang="en-US" sz="990" dirty="0"/>
           </a:p>
@@ -7520,7 +7342,7 @@
                 <a:ea typeface="Avenir Next" pitchFamily="34" charset="-122"/>
                 <a:cs typeface="Avenir Next" pitchFamily="34" charset="-120"/>
               </a:rPr>
-              <a:t>Changing PF geometry alone should not change the XY-only reference case.</a:t>
+              <a:t>[Expected behavior 3]</a:t>
             </a:r>
             <a:endParaRPr lang="en-US" sz="990" dirty="0"/>
           </a:p>
@@ -7599,7 +7421,7 @@
                 <a:ea typeface="Avenir Next" pitchFamily="34" charset="-122"/>
                 <a:cs typeface="Avenir Next" pitchFamily="34" charset="-120"/>
               </a:rPr>
-              <a:t>PF geometry changes alter XY-only behavior without the readout path engaged.</a:t>
+              <a:t>[Failure signature 1]</a:t>
             </a:r>
             <a:endParaRPr lang="en-US" sz="980" dirty="0"/>
           </a:p>
@@ -7617,7 +7439,7 @@
                 <a:ea typeface="Avenir Next" pitchFamily="34" charset="-122"/>
                 <a:cs typeface="Avenir Next" pitchFamily="34" charset="-120"/>
               </a:rPr>
-              <a:t>The mediated effect is larger than the direct interfaces without a clear explanation.</a:t>
+              <a:t>[Failure signature 2]</a:t>
             </a:r>
             <a:endParaRPr lang="en-US" sz="980" dirty="0"/>
           </a:p>
@@ -7635,7 +7457,7 @@
                 <a:ea typeface="Avenir Next" pitchFamily="34" charset="-122"/>
                 <a:cs typeface="Avenir Next" pitchFamily="34" charset="-120"/>
               </a:rPr>
-              <a:t>Path-breaking toggles fail to suppress the effect.</a:t>
+              <a:t>[Failure signature 3]</a:t>
             </a:r>
             <a:endParaRPr lang="en-US" sz="980" dirty="0"/>
           </a:p>
@@ -7730,7 +7552,7 @@
                 <a:ea typeface="Avenir Next" pitchFamily="34" charset="-122"/>
                 <a:cs typeface="Avenir Next" pitchFamily="34" charset="-120"/>
               </a:rPr>
-              <a:t>Actual behavior / plot slot</a:t>
+              <a:t>[Plot / notes area]</a:t>
             </a:r>
             <a:endParaRPr lang="en-US" sz="1100" dirty="0"/>
           </a:p>
@@ -7769,7 +7591,7 @@
                 <a:ea typeface="Avenir Next" pitchFamily="34" charset="-122"/>
                 <a:cs typeface="Avenir Next" pitchFamily="34" charset="-120"/>
               </a:rPr>
-              <a:t>Insert: XY-only versus XY+RO comparison with explicit path toggles.</a:t>
+              <a:t>Paste plot, table, or notes here.</a:t>
             </a:r>
             <a:endParaRPr lang="en-US" sz="1020" dirty="0"/>
           </a:p>
@@ -7808,7 +7630,7 @@
                 <a:ea typeface="Avenir Next" pitchFamily="34" charset="-122"/>
                 <a:cs typeface="Avenir Next" pitchFamily="34" charset="-120"/>
               </a:rPr>
-              <a:t>Recommended inserts</a:t>
+              <a:t>[Optional checklist]</a:t>
             </a:r>
             <a:endParaRPr lang="en-US" sz="970" dirty="0"/>
           </a:p>
@@ -7848,7 +7670,7 @@
                 <a:ea typeface="Avenir Next" pitchFamily="34" charset="-122"/>
                 <a:cs typeface="Avenir Next" pitchFamily="34" charset="-120"/>
               </a:rPr>
-              <a:t>One sweep plot with a monotonic knob on the x-axis</a:t>
+              <a:t>[Add visual 1]</a:t>
             </a:r>
             <a:endParaRPr lang="en-US" sz="950" dirty="0"/>
           </a:p>
@@ -7866,7 +7688,7 @@
                 <a:ea typeface="Avenir Next" pitchFamily="34" charset="-122"/>
                 <a:cs typeface="Avenir Next" pitchFamily="34" charset="-120"/>
               </a:rPr>
-              <a:t>One null-test or decoupling-limit comparison</a:t>
+              <a:t>[Add visual 2]</a:t>
             </a:r>
             <a:endParaRPr lang="en-US" sz="950" dirty="0"/>
           </a:p>
@@ -7884,48 +7706,9 @@
                 <a:ea typeface="Avenir Next" pitchFamily="34" charset="-122"/>
                 <a:cs typeface="Avenir Next" pitchFamily="34" charset="-120"/>
               </a:rPr>
-              <a:t>One sentence on whether the observed trend matches expectation</a:t>
+              <a:t>[Add short takeaway]</a:t>
             </a:r>
             <a:endParaRPr lang="en-US" sz="950" dirty="0"/>
-          </a:p>
-        </p:txBody>
-      </p:sp>
-      <p:sp>
-        <p:nvSpPr>
-          <p:cNvPr id="26" name="Text 24"/>
-          <p:cNvSpPr/>
-          <p:nvPr/>
-        </p:nvSpPr>
-        <p:spPr>
-          <a:xfrm>
-            <a:off x="749808" y="6473952"/>
-            <a:ext cx="5943600" cy="109728"/>
-          </a:xfrm>
-          <a:prstGeom prst="rect">
-            <a:avLst/>
-          </a:prstGeom>
-          <a:noFill/>
-          <a:ln/>
-        </p:spPr>
-        <p:txBody>
-          <a:bodyPr wrap="square" lIns="0" tIns="0" rIns="0" bIns="0" rtlCol="0" anchor="ctr"/>
-          <a:lstStyle/>
-          <a:p>
-            <a:pPr indent="0" marL="0">
-              <a:buNone/>
-            </a:pPr>
-            <a:r>
-              <a:rPr lang="en-US" sz="870" dirty="0">
-                <a:solidFill>
-                  <a:srgbClr val="667487"/>
-                </a:solidFill>
-                <a:latin typeface="Avenir Next" pitchFamily="34" charset="0"/>
-                <a:ea typeface="Avenir Next" pitchFamily="34" charset="-122"/>
-                <a:cs typeface="Avenir Next" pitchFamily="34" charset="-120"/>
-              </a:rPr>
-              <a:t>For mediated pairs, path-breaking null tests matter more than large parameter sweeps.</a:t>
-            </a:r>
-            <a:endParaRPr lang="en-US" sz="870" dirty="0"/>
           </a:p>
         </p:txBody>
       </p:sp>
@@ -8099,7 +7882,7 @@
                 <a:ea typeface="Avenir Next" pitchFamily="34" charset="-122"/>
                 <a:cs typeface="Avenir Next" pitchFamily="34" charset="-120"/>
               </a:rPr>
-              <a:t>How To Run The Audit</a:t>
+              <a:t>[Execution / appendix slide]</a:t>
             </a:r>
             <a:endParaRPr lang="en-US" sz="2200" dirty="0"/>
           </a:p>
@@ -8138,7 +7921,7 @@
                 <a:ea typeface="Avenir Next" pitchFamily="34" charset="-122"/>
                 <a:cs typeface="Avenir Next" pitchFamily="34" charset="-120"/>
               </a:rPr>
-              <a:t>This last slide turns the deck into a repeatable protocol instead of a one-off presentation.</a:t>
+              <a:t>[Add instructions or leave blank.]</a:t>
             </a:r>
             <a:endParaRPr lang="en-US" sz="1100" dirty="0"/>
           </a:p>
@@ -8204,7 +7987,7 @@
                 <a:ea typeface="Avenir Next" pitchFamily="34" charset="-122"/>
                 <a:cs typeface="Avenir Next" pitchFamily="34" charset="-120"/>
               </a:rPr>
-              <a:t>Per-Slide Fill-In Rule</a:t>
+              <a:t>[Left panel title]</a:t>
             </a:r>
             <a:endParaRPr lang="en-US" sz="1090" dirty="0"/>
           </a:p>
@@ -8244,7 +8027,7 @@
                 <a:ea typeface="Avenir Next" pitchFamily="34" charset="-122"/>
                 <a:cs typeface="Avenir Next" pitchFamily="34" charset="-120"/>
               </a:rPr>
-              <a:t>Name the parameter being swept and which structure or interface it belongs to.</a:t>
+              <a:t>[Item 1]</a:t>
             </a:r>
             <a:endParaRPr lang="en-US" sz="1020" dirty="0"/>
           </a:p>
@@ -8262,7 +8045,7 @@
                 <a:ea typeface="Avenir Next" pitchFamily="34" charset="-122"/>
                 <a:cs typeface="Avenir Next" pitchFamily="34" charset="-120"/>
               </a:rPr>
-              <a:t>State the expected matrix signature before showing the plot.</a:t>
+              <a:t>[Item 2]</a:t>
             </a:r>
             <a:endParaRPr lang="en-US" sz="1020" dirty="0"/>
           </a:p>
@@ -8280,7 +8063,7 @@
                 <a:ea typeface="Avenir Next" pitchFamily="34" charset="-122"/>
                 <a:cs typeface="Avenir Next" pitchFamily="34" charset="-120"/>
               </a:rPr>
-              <a:t>Add the actual plot and one sentence: matched / partially matched / failed.</a:t>
+              <a:t>[Item 3]</a:t>
             </a:r>
             <a:endParaRPr lang="en-US" sz="1020" dirty="0"/>
           </a:p>
@@ -8298,7 +8081,7 @@
                 <a:ea typeface="Avenir Next" pitchFamily="34" charset="-122"/>
                 <a:cs typeface="Avenir Next" pitchFamily="34" charset="-120"/>
               </a:rPr>
-              <a:t>If it fails, point to the first plausible implementation surface to inspect.</a:t>
+              <a:t>[Item 4]</a:t>
             </a:r>
             <a:endParaRPr lang="en-US" sz="1020" dirty="0"/>
           </a:p>
@@ -8337,7 +8120,7 @@
                 <a:ea typeface="Avenir Next" pitchFamily="34" charset="-122"/>
                 <a:cs typeface="Avenir Next" pitchFamily="34" charset="-120"/>
               </a:rPr>
-              <a:t>Recommended Score Columns</a:t>
+              <a:t>[Table / fields]</a:t>
             </a:r>
             <a:endParaRPr lang="en-US" sz="1090" dirty="0"/>
           </a:p>
@@ -8376,7 +8159,7 @@
                 <a:ea typeface="Menlo" pitchFamily="34" charset="-122"/>
                 <a:cs typeface="Menlo" pitchFamily="34" charset="-120"/>
               </a:rPr>
-              <a:t>structure_or_pair</a:t>
+              <a:t>[Field 1]</a:t>
             </a:r>
             <a:endParaRPr lang="en-US" sz="920" dirty="0"/>
           </a:p>
@@ -8393,7 +8176,7 @@
                 <a:ea typeface="Menlo" pitchFamily="34" charset="-122"/>
                 <a:cs typeface="Menlo" pitchFamily="34" charset="-120"/>
               </a:rPr>
-              <a:t>swept_knob</a:t>
+              <a:t>[Field 2]</a:t>
             </a:r>
             <a:endParaRPr lang="en-US" sz="920" dirty="0"/>
           </a:p>
@@ -8410,7 +8193,7 @@
                 <a:ea typeface="Menlo" pitchFamily="34" charset="-122"/>
                 <a:cs typeface="Menlo" pitchFamily="34" charset="-120"/>
               </a:rPr>
-              <a:t>primary_matrix_view</a:t>
+              <a:t>[Field 3]</a:t>
             </a:r>
             <a:endParaRPr lang="en-US" sz="920" dirty="0"/>
           </a:p>
@@ -8427,7 +8210,7 @@
                 <a:ea typeface="Menlo" pitchFamily="34" charset="-122"/>
                 <a:cs typeface="Menlo" pitchFamily="34" charset="-120"/>
               </a:rPr>
-              <a:t>expected_trend</a:t>
+              <a:t>[Field 4]</a:t>
             </a:r>
             <a:endParaRPr lang="en-US" sz="920" dirty="0"/>
           </a:p>
@@ -8444,41 +8227,7 @@
                 <a:ea typeface="Menlo" pitchFamily="34" charset="-122"/>
                 <a:cs typeface="Menlo" pitchFamily="34" charset="-120"/>
               </a:rPr>
-              <a:t>observed_trend</a:t>
-            </a:r>
-            <a:endParaRPr lang="en-US" sz="920" dirty="0"/>
-          </a:p>
-          <a:p>
-            <a:pPr indent="0" marL="0">
-              <a:buNone/>
-            </a:pPr>
-            <a:r>
-              <a:rPr lang="en-US" sz="920" dirty="0">
-                <a:solidFill>
-                  <a:srgbClr val="667487"/>
-                </a:solidFill>
-                <a:latin typeface="Menlo" pitchFamily="34" charset="0"/>
-                <a:ea typeface="Menlo" pitchFamily="34" charset="-122"/>
-                <a:cs typeface="Menlo" pitchFamily="34" charset="-120"/>
-              </a:rPr>
-              <a:t>pass_status</a:t>
-            </a:r>
-            <a:endParaRPr lang="en-US" sz="920" dirty="0"/>
-          </a:p>
-          <a:p>
-            <a:pPr indent="0" marL="0">
-              <a:buNone/>
-            </a:pPr>
-            <a:r>
-              <a:rPr lang="en-US" sz="920" dirty="0">
-                <a:solidFill>
-                  <a:srgbClr val="667487"/>
-                </a:solidFill>
-                <a:latin typeface="Menlo" pitchFamily="34" charset="0"/>
-                <a:ea typeface="Menlo" pitchFamily="34" charset="-122"/>
-                <a:cs typeface="Menlo" pitchFamily="34" charset="-120"/>
-              </a:rPr>
-              <a:t>confidence_delta</a:t>
+              <a:t>[Field 5]</a:t>
             </a:r>
             <a:endParaRPr lang="en-US" sz="920" dirty="0"/>
           </a:p>
@@ -8544,7 +8293,7 @@
                 <a:ea typeface="Avenir Next" pitchFamily="34" charset="-122"/>
                 <a:cs typeface="Avenir Next" pitchFamily="34" charset="-120"/>
               </a:rPr>
-              <a:t>Minimum Black-Box Test Set</a:t>
+              <a:t>[Right panel title]</a:t>
             </a:r>
             <a:endParaRPr lang="en-US" sz="1090" dirty="0"/>
           </a:p>
@@ -8584,7 +8333,7 @@
                 <a:ea typeface="Avenir Next" pitchFamily="34" charset="-122"/>
                 <a:cs typeface="Avenir Next" pitchFamily="34" charset="-120"/>
               </a:rPr>
-              <a:t>One monotonic self-sweep per structure</a:t>
+              <a:t>[Item 1]</a:t>
             </a:r>
             <a:endParaRPr lang="en-US" sz="1000" dirty="0"/>
           </a:p>
@@ -8602,7 +8351,7 @@
                 <a:ea typeface="Avenir Next" pitchFamily="34" charset="-122"/>
                 <a:cs typeface="Avenir Next" pitchFamily="34" charset="-120"/>
               </a:rPr>
-              <a:t>One zero-coupling or decoupling-limit test per direct interface</a:t>
+              <a:t>[Item 2]</a:t>
             </a:r>
             <a:endParaRPr lang="en-US" sz="1000" dirty="0"/>
           </a:p>
@@ -8620,7 +8369,7 @@
                 <a:ea typeface="Avenir Next" pitchFamily="34" charset="-122"/>
                 <a:cs typeface="Avenir Next" pitchFamily="34" charset="-120"/>
               </a:rPr>
-              <a:t>One path-breaking null test per mediated interface</a:t>
+              <a:t>[Item 3]</a:t>
             </a:r>
             <a:endParaRPr lang="en-US" sz="1000" dirty="0"/>
           </a:p>
@@ -8638,7 +8387,7 @@
                 <a:ea typeface="Avenir Next" pitchFamily="34" charset="-122"/>
                 <a:cs typeface="Avenir Next" pitchFamily="34" charset="-120"/>
               </a:rPr>
-              <a:t>One discretization or sweep-resolution refinement check on the final claim</a:t>
+              <a:t>[Item 4]</a:t>
             </a:r>
             <a:endParaRPr lang="en-US" sz="1000" dirty="0"/>
           </a:p>
@@ -8656,7 +8405,7 @@
                 <a:ea typeface="Avenir Next" pitchFamily="34" charset="-122"/>
                 <a:cs typeface="Avenir Next" pitchFamily="34" charset="-120"/>
               </a:rPr>
-              <a:t>One external-physics sanity check on magnitude or mode location</a:t>
+              <a:t>[Item 5]</a:t>
             </a:r>
             <a:endParaRPr lang="en-US" sz="1000" dirty="0"/>
           </a:p>
@@ -8695,7 +8444,7 @@
                 <a:ea typeface="Avenir Next" pitchFamily="34" charset="-122"/>
                 <a:cs typeface="Avenir Next" pitchFamily="34" charset="-120"/>
               </a:rPr>
-              <a:t>Decision Rule</a:t>
+              <a:t>[Decision / notes]</a:t>
             </a:r>
             <a:endParaRPr lang="en-US" sz="1090" dirty="0"/>
           </a:p>
@@ -8734,48 +8483,9 @@
                 <a:ea typeface="Avenir Next" pitchFamily="34" charset="-122"/>
                 <a:cs typeface="Avenir Next" pitchFamily="34" charset="-120"/>
               </a:rPr>
-              <a:t>Do not ask whether the implementation feels reasonable. Ask whether the necessary failure signatures stayed absent under the sweeps that should have exposed them first.</a:t>
+              <a:t>[Add final note or rule.]</a:t>
             </a:r>
             <a:endParaRPr lang="en-US" sz="1030" dirty="0"/>
-          </a:p>
-        </p:txBody>
-      </p:sp>
-      <p:sp>
-        <p:nvSpPr>
-          <p:cNvPr id="17" name="Text 15"/>
-          <p:cNvSpPr/>
-          <p:nvPr/>
-        </p:nvSpPr>
-        <p:spPr>
-          <a:xfrm>
-            <a:off x="749808" y="6473952"/>
-            <a:ext cx="5943600" cy="109728"/>
-          </a:xfrm>
-          <a:prstGeom prst="rect">
-            <a:avLst/>
-          </a:prstGeom>
-          <a:noFill/>
-          <a:ln/>
-        </p:spPr>
-        <p:txBody>
-          <a:bodyPr wrap="square" lIns="0" tIns="0" rIns="0" bIns="0" rtlCol="0" anchor="ctr"/>
-          <a:lstStyle/>
-          <a:p>
-            <a:pPr indent="0" marL="0">
-              <a:buNone/>
-            </a:pPr>
-            <a:r>
-              <a:rPr lang="en-US" sz="870" dirty="0">
-                <a:solidFill>
-                  <a:srgbClr val="667487"/>
-                </a:solidFill>
-                <a:latin typeface="Avenir Next" pitchFamily="34" charset="0"/>
-                <a:ea typeface="Avenir Next" pitchFamily="34" charset="-122"/>
-                <a:cs typeface="Avenir Next" pitchFamily="34" charset="-120"/>
-              </a:rPr>
-              <a:t>This protocol is designed for a researcher who cannot afford a full line-by-line code audit.</a:t>
-            </a:r>
-            <a:endParaRPr lang="en-US" sz="870" dirty="0"/>
           </a:p>
         </p:txBody>
       </p:sp>
@@ -8949,7 +8659,7 @@
                 <a:ea typeface="Avenir Next" pitchFamily="34" charset="-122"/>
                 <a:cs typeface="Avenir Next" pitchFamily="34" charset="-120"/>
               </a:rPr>
-              <a:t>Three-Part Verification Logic</a:t>
+              <a:t>[Method / framework slide]</a:t>
             </a:r>
             <a:endParaRPr lang="en-US" sz="2200" dirty="0"/>
           </a:p>
@@ -8988,7 +8698,7 @@
                 <a:ea typeface="Avenir Next" pitchFamily="34" charset="-122"/>
                 <a:cs typeface="Avenir Next" pitchFamily="34" charset="-120"/>
               </a:rPr>
-              <a:t>This deck is intentionally about verification first, solution verification second, and validation third.</a:t>
+              <a:t>[Add method summary or leave blank.]</a:t>
             </a:r>
             <a:endParaRPr lang="en-US" sz="1100" dirty="0"/>
           </a:p>
@@ -9093,7 +8803,7 @@
                 <a:ea typeface="Avenir Next" pitchFamily="34" charset="-122"/>
                 <a:cs typeface="Avenir Next" pitchFamily="34" charset="-120"/>
               </a:rPr>
-              <a:t>Did the code implement the intended mathematical structure? Use parameter-response checks and decoupling limits.</a:t>
+              <a:t>[Add criterion]</a:t>
             </a:r>
             <a:endParaRPr lang="en-US" sz="1020" dirty="0"/>
           </a:p>
@@ -9198,7 +8908,7 @@
                 <a:ea typeface="Avenir Next" pitchFamily="34" charset="-122"/>
                 <a:cs typeface="Avenir Next" pitchFamily="34" charset="-120"/>
               </a:rPr>
-              <a:t>Are discretization, sweep resolution, matching windows, and fitting settings converged enough for this claim?</a:t>
+              <a:t>[Add criterion]</a:t>
             </a:r>
             <a:endParaRPr lang="en-US" sz="1020" dirty="0"/>
           </a:p>
@@ -9303,7 +9013,7 @@
                 <a:ea typeface="Avenir Next" pitchFamily="34" charset="-122"/>
                 <a:cs typeface="Avenir Next" pitchFamily="34" charset="-120"/>
               </a:rPr>
-              <a:t>Do the trends and magnitudes still look like plausible physics, not only plausible numerics?</a:t>
+              <a:t>[Add criterion]</a:t>
             </a:r>
             <a:endParaRPr lang="en-US" sz="1020" dirty="0"/>
           </a:p>
@@ -9369,7 +9079,7 @@
                 <a:ea typeface="Avenir Next" pitchFamily="34" charset="-122"/>
                 <a:cs typeface="Avenir Next" pitchFamily="34" charset="-120"/>
               </a:rPr>
-              <a:t>Operational Rule For This Study</a:t>
+              <a:t>[Checklist / notes]</a:t>
             </a:r>
             <a:endParaRPr lang="en-US" sz="1090" dirty="0"/>
           </a:p>
@@ -9409,7 +9119,7 @@
                 <a:ea typeface="Avenir Next" pitchFamily="34" charset="-122"/>
                 <a:cs typeface="Avenir Next" pitchFamily="34" charset="-120"/>
               </a:rPr>
-              <a:t>Start with self-structure sweeps where the expected trend is simplest and strongest.</a:t>
+              <a:t>[Item 1]</a:t>
             </a:r>
             <a:endParaRPr lang="en-US" sz="1020" dirty="0"/>
           </a:p>
@@ -9427,7 +9137,7 @@
                 <a:ea typeface="Avenir Next" pitchFamily="34" charset="-122"/>
                 <a:cs typeface="Avenir Next" pitchFamily="34" charset="-120"/>
               </a:rPr>
-              <a:t>Move to direct interfaces and check monotonicity under the explicit coupling knob.</a:t>
+              <a:t>[Item 2]</a:t>
             </a:r>
             <a:endParaRPr lang="en-US" sz="1020" dirty="0"/>
           </a:p>
@@ -9445,48 +9155,9 @@
                 <a:ea typeface="Avenir Next" pitchFamily="34" charset="-122"/>
                 <a:cs typeface="Avenir Next" pitchFamily="34" charset="-120"/>
               </a:rPr>
-              <a:t>Treat the remaining three pairs as mediated only, and audit them with path-breaking null tests.</a:t>
+              <a:t>[Item 3]</a:t>
             </a:r>
             <a:endParaRPr lang="en-US" sz="1020" dirty="0"/>
-          </a:p>
-        </p:txBody>
-      </p:sp>
-      <p:sp>
-        <p:nvSpPr>
-          <p:cNvPr id="19" name="Text 17"/>
-          <p:cNvSpPr/>
-          <p:nvPr/>
-        </p:nvSpPr>
-        <p:spPr>
-          <a:xfrm>
-            <a:off x="749808" y="6473952"/>
-            <a:ext cx="5943600" cy="109728"/>
-          </a:xfrm>
-          <a:prstGeom prst="rect">
-            <a:avLst/>
-          </a:prstGeom>
-          <a:noFill/>
-          <a:ln/>
-        </p:spPr>
-        <p:txBody>
-          <a:bodyPr wrap="square" lIns="0" tIns="0" rIns="0" bIns="0" rtlCol="0" anchor="ctr"/>
-          <a:lstStyle/>
-          <a:p>
-            <a:pPr indent="0" marL="0">
-              <a:buNone/>
-            </a:pPr>
-            <a:r>
-              <a:rPr lang="en-US" sz="870" dirty="0">
-                <a:solidFill>
-                  <a:srgbClr val="667487"/>
-                </a:solidFill>
-                <a:latin typeface="Avenir Next" pitchFamily="34" charset="0"/>
-                <a:ea typeface="Avenir Next" pitchFamily="34" charset="-122"/>
-                <a:cs typeface="Avenir Next" pitchFamily="34" charset="-120"/>
-              </a:rPr>
-              <a:t>The report should make it obvious what would have broken first if the implementation were wrong.</a:t>
-            </a:r>
-            <a:endParaRPr lang="en-US" sz="870" dirty="0"/>
           </a:p>
         </p:txBody>
       </p:sp>
@@ -9660,7 +9331,7 @@
                 <a:ea typeface="Avenir Next" pitchFamily="34" charset="-122"/>
                 <a:cs typeface="Avenir Next" pitchFamily="34" charset="-120"/>
               </a:rPr>
-              <a:t>Model Topology Used By The Audit</a:t>
+              <a:t>[Topology / diagram slide]</a:t>
             </a:r>
             <a:endParaRPr lang="en-US" sz="2200" dirty="0"/>
           </a:p>
@@ -9699,7 +9370,7 @@
                 <a:ea typeface="Avenir Next" pitchFamily="34" charset="-122"/>
                 <a:cs typeface="Avenir Next" pitchFamily="34" charset="-120"/>
               </a:rPr>
-              <a:t>This summary matters because some interfaces are direct in the netlist, while others are only mediated through an intermediate path.</a:t>
+              <a:t>[Add context or leave blank.]</a:t>
             </a:r>
             <a:endParaRPr lang="en-US" sz="1100" dirty="0"/>
           </a:p>
@@ -9729,45 +9400,6 @@
           </a:prstGeom>
         </p:spPr>
       </p:pic>
-      <p:sp>
-        <p:nvSpPr>
-          <p:cNvPr id="8" name="Text 5"/>
-          <p:cNvSpPr/>
-          <p:nvPr/>
-        </p:nvSpPr>
-        <p:spPr>
-          <a:xfrm>
-            <a:off x="749808" y="6473952"/>
-            <a:ext cx="5943600" cy="109728"/>
-          </a:xfrm>
-          <a:prstGeom prst="rect">
-            <a:avLst/>
-          </a:prstGeom>
-          <a:noFill/>
-          <a:ln/>
-        </p:spPr>
-        <p:txBody>
-          <a:bodyPr wrap="square" lIns="0" tIns="0" rIns="0" bIns="0" rtlCol="0" anchor="ctr"/>
-          <a:lstStyle/>
-          <a:p>
-            <a:pPr indent="0" marL="0">
-              <a:buNone/>
-            </a:pPr>
-            <a:r>
-              <a:rPr lang="en-US" sz="870" dirty="0">
-                <a:solidFill>
-                  <a:srgbClr val="667487"/>
-                </a:solidFill>
-                <a:latin typeface="Avenir Next" pitchFamily="34" charset="0"/>
-                <a:ea typeface="Avenir Next" pitchFamily="34" charset="-122"/>
-                <a:cs typeface="Avenir Next" pitchFamily="34" charset="-120"/>
-              </a:rPr>
-              <a:t>A good verification report should respect the actual topology of the study model, not only the physical story we tell around it.</a:t>
-            </a:r>
-            <a:endParaRPr lang="en-US" sz="870" dirty="0"/>
-          </a:p>
-        </p:txBody>
-      </p:sp>
     </p:spTree>
   </p:cSld>
   <p:clrMapOvr>
@@ -9938,7 +9570,7 @@
                 <a:ea typeface="Avenir Next" pitchFamily="34" charset="-122"/>
                 <a:cs typeface="Avenir Next" pitchFamily="34" charset="-120"/>
               </a:rPr>
-              <a:t>Pairwise Audit Inventory</a:t>
+              <a:t>[Inventory / matrix slide]</a:t>
             </a:r>
             <a:endParaRPr lang="en-US" sz="2200" dirty="0"/>
           </a:p>
@@ -9977,7 +9609,7 @@
                 <a:ea typeface="Avenir Next" pitchFamily="34" charset="-122"/>
                 <a:cs typeface="Avenir Next" pitchFamily="34" charset="-120"/>
               </a:rPr>
-              <a:t>Direct interfaces get sweep-based checks. Mediated interfaces get null checks and path-breaking checks.</a:t>
+              <a:t>[Add context or leave blank.]</a:t>
             </a:r>
             <a:endParaRPr lang="en-US" sz="1100" dirty="0"/>
           </a:p>
@@ -10007,45 +9639,6 @@
           </a:prstGeom>
         </p:spPr>
       </p:pic>
-      <p:sp>
-        <p:nvSpPr>
-          <p:cNvPr id="8" name="Text 5"/>
-          <p:cNvSpPr/>
-          <p:nvPr/>
-        </p:nvSpPr>
-        <p:spPr>
-          <a:xfrm>
-            <a:off x="749808" y="6473952"/>
-            <a:ext cx="5943600" cy="109728"/>
-          </a:xfrm>
-          <a:prstGeom prst="rect">
-            <a:avLst/>
-          </a:prstGeom>
-          <a:noFill/>
-          <a:ln/>
-        </p:spPr>
-        <p:txBody>
-          <a:bodyPr wrap="square" lIns="0" tIns="0" rIns="0" bIns="0" rtlCol="0" anchor="ctr"/>
-          <a:lstStyle/>
-          <a:p>
-            <a:pPr indent="0" marL="0">
-              <a:buNone/>
-            </a:pPr>
-            <a:r>
-              <a:rPr lang="en-US" sz="870" dirty="0">
-                <a:solidFill>
-                  <a:srgbClr val="667487"/>
-                </a:solidFill>
-                <a:latin typeface="Avenir Next" pitchFamily="34" charset="0"/>
-                <a:ea typeface="Avenir Next" pitchFamily="34" charset="-122"/>
-                <a:cs typeface="Avenir Next" pitchFamily="34" charset="-120"/>
-              </a:rPr>
-              <a:t>This slide is the transition point between subsystem pages and pairwise-interface pages.</a:t>
-            </a:r>
-            <a:endParaRPr lang="en-US" sz="870" dirty="0"/>
-          </a:p>
-        </p:txBody>
-      </p:sp>
     </p:spTree>
   </p:cSld>
   <p:clrMapOvr>
@@ -10255,7 +9848,7 @@
                 <a:ea typeface="Avenir Next" pitchFamily="34" charset="-122"/>
                 <a:cs typeface="Avenir Next" pitchFamily="34" charset="-120"/>
               </a:rPr>
-              <a:t>Treat the qubit as the reference oscillator. This is where monotonicity checks should be easiest and where nonphysical loss should be easiest to spot.</a:t>
+              <a:t>[Add one-line framing for this structure.]</a:t>
             </a:r>
             <a:endParaRPr lang="en-US" sz="1100" dirty="0"/>
           </a:p>
@@ -10360,7 +9953,7 @@
                 <a:ea typeface="Menlo" pitchFamily="34" charset="-122"/>
                 <a:cs typeface="Menlo" pitchFamily="34" charset="-120"/>
               </a:rPr>
-              <a:t>l_q_h</a:t>
+              <a:t>[Parameter 1]</a:t>
             </a:r>
             <a:endParaRPr lang="en-US" sz="920" dirty="0"/>
           </a:p>
@@ -10377,7 +9970,7 @@
                 <a:ea typeface="Menlo" pitchFamily="34" charset="-122"/>
                 <a:cs typeface="Menlo" pitchFamily="34" charset="-120"/>
               </a:rPr>
-              <a:t>c_q_f</a:t>
+              <a:t>[Parameter 2]</a:t>
             </a:r>
             <a:endParaRPr lang="en-US" sz="920" dirty="0"/>
           </a:p>
@@ -10394,24 +9987,7 @@
                 <a:ea typeface="Menlo" pitchFamily="34" charset="-122"/>
                 <a:cs typeface="Menlo" pitchFamily="34" charset="-120"/>
               </a:rPr>
-              <a:t>c_g1_f, c_g2_f</a:t>
-            </a:r>
-            <a:endParaRPr lang="en-US" sz="920" dirty="0"/>
-          </a:p>
-          <a:p>
-            <a:pPr indent="0" marL="0">
-              <a:buNone/>
-            </a:pPr>
-            <a:r>
-              <a:rPr lang="en-US" sz="920" dirty="0">
-                <a:solidFill>
-                  <a:srgbClr val="667487"/>
-                </a:solidFill>
-                <a:latin typeface="Menlo" pitchFamily="34" charset="0"/>
-                <a:ea typeface="Menlo" pitchFamily="34" charset="-122"/>
-                <a:cs typeface="Menlo" pitchFamily="34" charset="-120"/>
-              </a:rPr>
-              <a:t>qubit_port_res_ohm</a:t>
+              <a:t>[Parameter 3]</a:t>
             </a:r>
             <a:endParaRPr lang="en-US" sz="920" dirty="0"/>
           </a:p>
@@ -10516,7 +10092,7 @@
                 <a:ea typeface="Avenir Next" pitchFamily="34" charset="-122"/>
                 <a:cs typeface="Avenir Next" pitchFamily="34" charset="-120"/>
               </a:rPr>
-              <a:t>Primary observable: reduced Ydm,in(ω), extracted fq from Im(Ydm,in)=0, and Re(Ydm,in) at resonance.</a:t>
+              <a:t>[Add primary matrix / observable for this structure.]</a:t>
             </a:r>
             <a:endParaRPr lang="en-US" sz="1010" dirty="0"/>
           </a:p>
@@ -10622,7 +10198,7 @@
                 <a:ea typeface="Avenir Next" pitchFamily="34" charset="-122"/>
                 <a:cs typeface="Avenir Next" pitchFamily="34" charset="-120"/>
               </a:rPr>
-              <a:t>Lq up should move fq down.</a:t>
+              <a:t>[Expected response 1]</a:t>
             </a:r>
             <a:endParaRPr lang="en-US" sz="990" dirty="0"/>
           </a:p>
@@ -10640,7 +10216,7 @@
                 <a:ea typeface="Avenir Next" pitchFamily="34" charset="-122"/>
                 <a:cs typeface="Avenir Next" pitchFamily="34" charset="-120"/>
               </a:rPr>
-              <a:t>Cq or pad-to-ground capacitance up should move fq down.</a:t>
+              <a:t>[Expected response 2]</a:t>
             </a:r>
             <a:endParaRPr lang="en-US" sz="990" dirty="0"/>
           </a:p>
@@ -10658,89 +10234,89 @@
                 <a:ea typeface="Avenir Next" pitchFamily="34" charset="-122"/>
                 <a:cs typeface="Avenir Next" pitchFamily="34" charset="-120"/>
               </a:rPr>
-              <a:t>With c_xy = c_rq = 0, Re(Ydm,in) should stay small and smooth.</a:t>
+              <a:t>[Expected response 3]</a:t>
             </a:r>
             <a:endParaRPr lang="en-US" sz="990" dirty="0"/>
           </a:p>
+        </p:txBody>
+      </p:sp>
+      <p:sp>
+        <p:nvSpPr>
+          <p:cNvPr id="16" name="Text 14"/>
+          <p:cNvSpPr/>
+          <p:nvPr/>
+        </p:nvSpPr>
+        <p:spPr>
+          <a:xfrm>
+            <a:off x="4370832" y="4114800"/>
+            <a:ext cx="2743200" cy="164592"/>
+          </a:xfrm>
+          <a:prstGeom prst="rect">
+            <a:avLst/>
+          </a:prstGeom>
+          <a:noFill/>
+          <a:ln/>
+        </p:spPr>
+        <p:txBody>
+          <a:bodyPr wrap="square" lIns="0" tIns="0" rIns="0" bIns="0" rtlCol="0" anchor="ctr"/>
+          <a:lstStyle/>
+          <a:p>
+            <a:pPr indent="0" marL="0">
+              <a:buNone/>
+            </a:pPr>
+            <a:r>
+              <a:rPr lang="en-US" sz="1090" b="1" dirty="0">
+                <a:solidFill>
+                  <a:srgbClr val="10233A"/>
+                </a:solidFill>
+                <a:latin typeface="Avenir Next" pitchFamily="34" charset="0"/>
+                <a:ea typeface="Avenir Next" pitchFamily="34" charset="-122"/>
+                <a:cs typeface="Avenir Next" pitchFamily="34" charset="-120"/>
+              </a:rPr>
+              <a:t>What Counts As A Good Sign</a:t>
+            </a:r>
+            <a:endParaRPr lang="en-US" sz="1090" dirty="0"/>
+          </a:p>
+        </p:txBody>
+      </p:sp>
+      <p:sp>
+        <p:nvSpPr>
+          <p:cNvPr id="17" name="Text 15"/>
+          <p:cNvSpPr/>
+          <p:nvPr/>
+        </p:nvSpPr>
+        <p:spPr>
+          <a:xfrm>
+            <a:off x="4315968" y="4425696"/>
+            <a:ext cx="2907792" cy="768096"/>
+          </a:xfrm>
+          <a:prstGeom prst="rect">
+            <a:avLst/>
+          </a:prstGeom>
+          <a:noFill/>
+          <a:ln/>
+        </p:spPr>
+        <p:txBody>
+          <a:bodyPr wrap="square" lIns="0" tIns="0" rIns="0" bIns="0" rtlCol="0" anchor="t"/>
+          <a:lstStyle/>
           <a:p>
             <a:pPr marL="152400" indent="-152400">
               <a:buSzPct val="100000"/>
               <a:buChar char="•"/>
             </a:pPr>
             <a:r>
-              <a:rPr lang="en-US" sz="990" dirty="0">
-                <a:solidFill>
-                  <a:srgbClr val="10233A"/>
-                </a:solidFill>
-                <a:latin typeface="Avenir Next" pitchFamily="34" charset="0"/>
-                <a:ea typeface="Avenir Next" pitchFamily="34" charset="-122"/>
-                <a:cs typeface="Avenir Next" pitchFamily="34" charset="-120"/>
-              </a:rPr>
-              <a:t>Pad asymmetry should affect CM/DM weighting, not spawn unrelated resonances.</a:t>
-            </a:r>
-            <a:endParaRPr lang="en-US" sz="990" dirty="0"/>
-          </a:p>
-        </p:txBody>
-      </p:sp>
-      <p:sp>
-        <p:nvSpPr>
-          <p:cNvPr id="16" name="Text 14"/>
-          <p:cNvSpPr/>
-          <p:nvPr/>
-        </p:nvSpPr>
-        <p:spPr>
-          <a:xfrm>
-            <a:off x="4370832" y="4114800"/>
-            <a:ext cx="2743200" cy="164592"/>
-          </a:xfrm>
-          <a:prstGeom prst="rect">
-            <a:avLst/>
-          </a:prstGeom>
-          <a:noFill/>
-          <a:ln/>
-        </p:spPr>
-        <p:txBody>
-          <a:bodyPr wrap="square" lIns="0" tIns="0" rIns="0" bIns="0" rtlCol="0" anchor="ctr"/>
-          <a:lstStyle/>
-          <a:p>
-            <a:pPr indent="0" marL="0">
-              <a:buNone/>
-            </a:pPr>
-            <a:r>
-              <a:rPr lang="en-US" sz="1090" b="1" dirty="0">
-                <a:solidFill>
-                  <a:srgbClr val="10233A"/>
-                </a:solidFill>
-                <a:latin typeface="Avenir Next" pitchFamily="34" charset="0"/>
-                <a:ea typeface="Avenir Next" pitchFamily="34" charset="-122"/>
-                <a:cs typeface="Avenir Next" pitchFamily="34" charset="-120"/>
-              </a:rPr>
-              <a:t>What Counts As A Good Sign</a:t>
-            </a:r>
-            <a:endParaRPr lang="en-US" sz="1090" dirty="0"/>
-          </a:p>
-        </p:txBody>
-      </p:sp>
-      <p:sp>
-        <p:nvSpPr>
-          <p:cNvPr id="17" name="Text 15"/>
-          <p:cNvSpPr/>
-          <p:nvPr/>
-        </p:nvSpPr>
-        <p:spPr>
-          <a:xfrm>
-            <a:off x="4315968" y="4425696"/>
-            <a:ext cx="2907792" cy="768096"/>
-          </a:xfrm>
-          <a:prstGeom prst="rect">
-            <a:avLst/>
-          </a:prstGeom>
-          <a:noFill/>
-          <a:ln/>
-        </p:spPr>
-        <p:txBody>
-          <a:bodyPr wrap="square" lIns="0" tIns="0" rIns="0" bIns="0" rtlCol="0" anchor="t"/>
-          <a:lstStyle/>
+              <a:rPr lang="en-US" sz="980" dirty="0">
+                <a:solidFill>
+                  <a:srgbClr val="10233A"/>
+                </a:solidFill>
+                <a:latin typeface="Avenir Next" pitchFamily="34" charset="0"/>
+                <a:ea typeface="Avenir Next" pitchFamily="34" charset="-122"/>
+                <a:cs typeface="Avenir Next" pitchFamily="34" charset="-120"/>
+              </a:rPr>
+              <a:t>[Pass signal 1]</a:t>
+            </a:r>
+            <a:endParaRPr lang="en-US" sz="980" dirty="0"/>
+          </a:p>
           <a:p>
             <a:pPr marL="152400" indent="-152400">
               <a:buSzPct val="100000"/>
@@ -10755,7 +10331,7 @@
                 <a:ea typeface="Avenir Next" pitchFamily="34" charset="-122"/>
                 <a:cs typeface="Avenir Next" pitchFamily="34" charset="-120"/>
               </a:rPr>
-              <a:t>Zero crossing moves monotonically under parameter sweeps.</a:t>
+              <a:t>[Pass signal 2]</a:t>
             </a:r>
             <a:endParaRPr lang="en-US" sz="980" dirty="0"/>
           </a:p>
@@ -10773,25 +10349,7 @@
                 <a:ea typeface="Avenir Next" pitchFamily="34" charset="-122"/>
                 <a:cs typeface="Avenir Next" pitchFamily="34" charset="-120"/>
               </a:rPr>
-              <a:t>Retuning the bare qubit does not suddenly create large loss.</a:t>
-            </a:r>
-            <a:endParaRPr lang="en-US" sz="980" dirty="0"/>
-          </a:p>
-          <a:p>
-            <a:pPr marL="152400" indent="-152400">
-              <a:buSzPct val="100000"/>
-              <a:buChar char="•"/>
-            </a:pPr>
-            <a:r>
-              <a:rPr lang="en-US" sz="980" dirty="0">
-                <a:solidFill>
-                  <a:srgbClr val="10233A"/>
-                </a:solidFill>
-                <a:latin typeface="Avenir Next" pitchFamily="34" charset="0"/>
-                <a:ea typeface="Avenir Next" pitchFamily="34" charset="-122"/>
-                <a:cs typeface="Avenir Next" pitchFamily="34" charset="-120"/>
-              </a:rPr>
-              <a:t>Frequency extraction is stable under sweep refinement.</a:t>
+              <a:t>[Pass signal 3]</a:t>
             </a:r>
             <a:endParaRPr lang="en-US" sz="980" dirty="0"/>
           </a:p>
@@ -10886,7 +10444,7 @@
                 <a:ea typeface="Avenir Next" pitchFamily="34" charset="-122"/>
                 <a:cs typeface="Avenir Next" pitchFamily="34" charset="-120"/>
               </a:rPr>
-              <a:t>Actual behavior / plot slot</a:t>
+              <a:t>[Plot / notes area]</a:t>
             </a:r>
             <a:endParaRPr lang="en-US" sz="1100" dirty="0"/>
           </a:p>
@@ -10925,7 +10483,7 @@
                 <a:ea typeface="Avenir Next" pitchFamily="34" charset="-122"/>
                 <a:cs typeface="Avenir Next" pitchFamily="34" charset="-120"/>
               </a:rPr>
-              <a:t>Insert: Lq sweep, Im(Ydm,in) zero-crossing traces, and one isolated-qubit sanity plot.</a:t>
+              <a:t>Paste plot, table, or notes here.</a:t>
             </a:r>
             <a:endParaRPr lang="en-US" sz="1020" dirty="0"/>
           </a:p>
@@ -10964,7 +10522,7 @@
                 <a:ea typeface="Avenir Next" pitchFamily="34" charset="-122"/>
                 <a:cs typeface="Avenir Next" pitchFamily="34" charset="-120"/>
               </a:rPr>
-              <a:t>Recommended inserts</a:t>
+              <a:t>[Optional checklist]</a:t>
             </a:r>
             <a:endParaRPr lang="en-US" sz="970" dirty="0"/>
           </a:p>
@@ -11004,7 +10562,7 @@
                 <a:ea typeface="Avenir Next" pitchFamily="34" charset="-122"/>
                 <a:cs typeface="Avenir Next" pitchFamily="34" charset="-120"/>
               </a:rPr>
-              <a:t>One sweep plot with a monotonic knob on the x-axis</a:t>
+              <a:t>[Add visual 1]</a:t>
             </a:r>
             <a:endParaRPr lang="en-US" sz="950" dirty="0"/>
           </a:p>
@@ -11022,7 +10580,7 @@
                 <a:ea typeface="Avenir Next" pitchFamily="34" charset="-122"/>
                 <a:cs typeface="Avenir Next" pitchFamily="34" charset="-120"/>
               </a:rPr>
-              <a:t>One null-test or decoupling-limit comparison</a:t>
+              <a:t>[Add visual 2]</a:t>
             </a:r>
             <a:endParaRPr lang="en-US" sz="950" dirty="0"/>
           </a:p>
@@ -11040,48 +10598,9 @@
                 <a:ea typeface="Avenir Next" pitchFamily="34" charset="-122"/>
                 <a:cs typeface="Avenir Next" pitchFamily="34" charset="-120"/>
               </a:rPr>
-              <a:t>One sentence on whether the observed trend matches expectation</a:t>
+              <a:t>[Add short takeaway]</a:t>
             </a:r>
             <a:endParaRPr lang="en-US" sz="950" dirty="0"/>
-          </a:p>
-        </p:txBody>
-      </p:sp>
-      <p:sp>
-        <p:nvSpPr>
-          <p:cNvPr id="24" name="Text 22"/>
-          <p:cNvSpPr/>
-          <p:nvPr/>
-        </p:nvSpPr>
-        <p:spPr>
-          <a:xfrm>
-            <a:off x="749808" y="6473952"/>
-            <a:ext cx="5943600" cy="109728"/>
-          </a:xfrm>
-          <a:prstGeom prst="rect">
-            <a:avLst/>
-          </a:prstGeom>
-          <a:noFill/>
-          <a:ln/>
-        </p:spPr>
-        <p:txBody>
-          <a:bodyPr wrap="square" lIns="0" tIns="0" rIns="0" bIns="0" rtlCol="0" anchor="ctr"/>
-          <a:lstStyle/>
-          <a:p>
-            <a:pPr indent="0" marL="0">
-              <a:buNone/>
-            </a:pPr>
-            <a:r>
-              <a:rPr lang="en-US" sz="870" dirty="0">
-                <a:solidFill>
-                  <a:srgbClr val="667487"/>
-                </a:solidFill>
-                <a:latin typeface="Avenir Next" pitchFamily="34" charset="0"/>
-                <a:ea typeface="Avenir Next" pitchFamily="34" charset="-122"/>
-                <a:cs typeface="Avenir Next" pitchFamily="34" charset="-120"/>
-              </a:rPr>
-              <a:t>Front section: first explain the structure, then explain what the structure should do when its own knobs are swept.</a:t>
-            </a:r>
-            <a:endParaRPr lang="en-US" sz="870" dirty="0"/>
           </a:p>
         </p:txBody>
       </p:sp>
@@ -11294,7 +10813,7 @@
                 <a:ea typeface="Avenir Next" pitchFamily="34" charset="-122"/>
                 <a:cs typeface="Avenir Next" pitchFamily="34" charset="-120"/>
               </a:rPr>
-              <a:t>In this study the readout resonator is the quarter-wave resonator branch coupled into the readout line through the coupled window.</a:t>
+              <a:t>[Add one-line framing for this structure.]</a:t>
             </a:r>
             <a:endParaRPr lang="en-US" sz="1100" dirty="0"/>
           </a:p>
@@ -11399,7 +10918,7 @@
                 <a:ea typeface="Menlo" pitchFamily="34" charset="-122"/>
                 <a:cs typeface="Menlo" pitchFamily="34" charset="-120"/>
               </a:rPr>
-              <a:t>qwr_length_m</a:t>
+              <a:t>[Parameter 1]</a:t>
             </a:r>
             <a:endParaRPr lang="en-US" sz="920" dirty="0"/>
           </a:p>
@@ -11416,7 +10935,7 @@
                 <a:ea typeface="Menlo" pitchFamily="34" charset="-122"/>
                 <a:cs typeface="Menlo" pitchFamily="34" charset="-120"/>
               </a:rPr>
-              <a:t>common_l_per_m_h, common_c_per_m_f</a:t>
+              <a:t>[Parameter 2]</a:t>
             </a:r>
             <a:endParaRPr lang="en-US" sz="920" dirty="0"/>
           </a:p>
@@ -11433,24 +10952,7 @@
                 <a:ea typeface="Menlo" pitchFamily="34" charset="-122"/>
                 <a:cs typeface="Menlo" pitchFamily="34" charset="-120"/>
               </a:rPr>
-              <a:t>common_r_per_m_ohm, common_g_per_m_s</a:t>
-            </a:r>
-            <a:endParaRPr lang="en-US" sz="920" dirty="0"/>
-          </a:p>
-          <a:p>
-            <a:pPr indent="0" marL="0">
-              <a:buNone/>
-            </a:pPr>
-            <a:r>
-              <a:rPr lang="en-US" sz="920" dirty="0">
-                <a:solidFill>
-                  <a:srgbClr val="667487"/>
-                </a:solidFill>
-                <a:latin typeface="Menlo" pitchFamily="34" charset="0"/>
-                <a:ea typeface="Menlo" pitchFamily="34" charset="-122"/>
-                <a:cs typeface="Menlo" pitchFamily="34" charset="-120"/>
-              </a:rPr>
-              <a:t>qwr_target_dz_m</a:t>
+              <a:t>[Parameter 3]</a:t>
             </a:r>
             <a:endParaRPr lang="en-US" sz="920" dirty="0"/>
           </a:p>
@@ -11555,7 +11057,7 @@
                 <a:ea typeface="Avenir Next" pitchFamily="34" charset="-122"/>
                 <a:cs typeface="Avenir Next" pitchFamily="34" charset="-120"/>
               </a:rPr>
-              <a:t>Primary observable: readout-line S21, fitted resonator poles from vector fitting, and optional local Y before reduction.</a:t>
+              <a:t>[Add primary matrix / observable for this structure.]</a:t>
             </a:r>
             <a:endParaRPr lang="en-US" sz="1010" dirty="0"/>
           </a:p>
@@ -11661,7 +11163,7 @@
                 <a:ea typeface="Avenir Next" pitchFamily="34" charset="-122"/>
                 <a:cs typeface="Avenir Next" pitchFamily="34" charset="-120"/>
               </a:rPr>
-              <a:t>Longer electrical length should move the readout-resonator resonance lower.</a:t>
+              <a:t>[Expected response 1]</a:t>
             </a:r>
             <a:endParaRPr lang="en-US" sz="990" dirty="0"/>
           </a:p>
@@ -11679,7 +11181,7 @@
                 <a:ea typeface="Avenir Next" pitchFamily="34" charset="-122"/>
                 <a:cs typeface="Avenir Next" pitchFamily="34" charset="-120"/>
               </a:rPr>
-              <a:t>Changing common RLGC should shift distributed resonances consistently, not arbitrarily.</a:t>
+              <a:t>[Expected response 2]</a:t>
             </a:r>
             <a:endParaRPr lang="en-US" sz="990" dirty="0"/>
           </a:p>
@@ -11697,89 +11199,89 @@
                 <a:ea typeface="Avenir Next" pitchFamily="34" charset="-122"/>
                 <a:cs typeface="Avenir Next" pitchFamily="34" charset="-120"/>
               </a:rPr>
-              <a:t>If c_rq1 = c_rq2 = 0, retuning the resonator should not move the qubit result.</a:t>
+              <a:t>[Expected response 3]</a:t>
             </a:r>
             <a:endParaRPr lang="en-US" sz="990" dirty="0"/>
           </a:p>
+        </p:txBody>
+      </p:sp>
+      <p:sp>
+        <p:nvSpPr>
+          <p:cNvPr id="16" name="Text 14"/>
+          <p:cNvSpPr/>
+          <p:nvPr/>
+        </p:nvSpPr>
+        <p:spPr>
+          <a:xfrm>
+            <a:off x="4370832" y="4114800"/>
+            <a:ext cx="2743200" cy="164592"/>
+          </a:xfrm>
+          <a:prstGeom prst="rect">
+            <a:avLst/>
+          </a:prstGeom>
+          <a:noFill/>
+          <a:ln/>
+        </p:spPr>
+        <p:txBody>
+          <a:bodyPr wrap="square" lIns="0" tIns="0" rIns="0" bIns="0" rtlCol="0" anchor="ctr"/>
+          <a:lstStyle/>
+          <a:p>
+            <a:pPr indent="0" marL="0">
+              <a:buNone/>
+            </a:pPr>
+            <a:r>
+              <a:rPr lang="en-US" sz="1090" b="1" dirty="0">
+                <a:solidFill>
+                  <a:srgbClr val="10233A"/>
+                </a:solidFill>
+                <a:latin typeface="Avenir Next" pitchFamily="34" charset="0"/>
+                <a:ea typeface="Avenir Next" pitchFamily="34" charset="-122"/>
+                <a:cs typeface="Avenir Next" pitchFamily="34" charset="-120"/>
+              </a:rPr>
+              <a:t>What Counts As A Good Sign</a:t>
+            </a:r>
+            <a:endParaRPr lang="en-US" sz="1090" dirty="0"/>
+          </a:p>
+        </p:txBody>
+      </p:sp>
+      <p:sp>
+        <p:nvSpPr>
+          <p:cNvPr id="17" name="Text 15"/>
+          <p:cNvSpPr/>
+          <p:nvPr/>
+        </p:nvSpPr>
+        <p:spPr>
+          <a:xfrm>
+            <a:off x="4315968" y="4425696"/>
+            <a:ext cx="2907792" cy="768096"/>
+          </a:xfrm>
+          <a:prstGeom prst="rect">
+            <a:avLst/>
+          </a:prstGeom>
+          <a:noFill/>
+          <a:ln/>
+        </p:spPr>
+        <p:txBody>
+          <a:bodyPr wrap="square" lIns="0" tIns="0" rIns="0" bIns="0" rtlCol="0" anchor="t"/>
+          <a:lstStyle/>
           <a:p>
             <a:pPr marL="152400" indent="-152400">
               <a:buSzPct val="100000"/>
               <a:buChar char="•"/>
             </a:pPr>
             <a:r>
-              <a:rPr lang="en-US" sz="990" dirty="0">
-                <a:solidFill>
-                  <a:srgbClr val="10233A"/>
-                </a:solidFill>
-                <a:latin typeface="Avenir Next" pitchFamily="34" charset="0"/>
-                <a:ea typeface="Avenir Next" pitchFamily="34" charset="-122"/>
-                <a:cs typeface="Avenir Next" pitchFamily="34" charset="-120"/>
-              </a:rPr>
-              <a:t>Mesh refinement should converge mode locations instead of reordering them.</a:t>
-            </a:r>
-            <a:endParaRPr lang="en-US" sz="990" dirty="0"/>
-          </a:p>
-        </p:txBody>
-      </p:sp>
-      <p:sp>
-        <p:nvSpPr>
-          <p:cNvPr id="16" name="Text 14"/>
-          <p:cNvSpPr/>
-          <p:nvPr/>
-        </p:nvSpPr>
-        <p:spPr>
-          <a:xfrm>
-            <a:off x="4370832" y="4114800"/>
-            <a:ext cx="2743200" cy="164592"/>
-          </a:xfrm>
-          <a:prstGeom prst="rect">
-            <a:avLst/>
-          </a:prstGeom>
-          <a:noFill/>
-          <a:ln/>
-        </p:spPr>
-        <p:txBody>
-          <a:bodyPr wrap="square" lIns="0" tIns="0" rIns="0" bIns="0" rtlCol="0" anchor="ctr"/>
-          <a:lstStyle/>
-          <a:p>
-            <a:pPr indent="0" marL="0">
-              <a:buNone/>
-            </a:pPr>
-            <a:r>
-              <a:rPr lang="en-US" sz="1090" b="1" dirty="0">
-                <a:solidFill>
-                  <a:srgbClr val="10233A"/>
-                </a:solidFill>
-                <a:latin typeface="Avenir Next" pitchFamily="34" charset="0"/>
-                <a:ea typeface="Avenir Next" pitchFamily="34" charset="-122"/>
-                <a:cs typeface="Avenir Next" pitchFamily="34" charset="-120"/>
-              </a:rPr>
-              <a:t>What Counts As A Good Sign</a:t>
-            </a:r>
-            <a:endParaRPr lang="en-US" sz="1090" dirty="0"/>
-          </a:p>
-        </p:txBody>
-      </p:sp>
-      <p:sp>
-        <p:nvSpPr>
-          <p:cNvPr id="17" name="Text 15"/>
-          <p:cNvSpPr/>
-          <p:nvPr/>
-        </p:nvSpPr>
-        <p:spPr>
-          <a:xfrm>
-            <a:off x="4315968" y="4425696"/>
-            <a:ext cx="2907792" cy="768096"/>
-          </a:xfrm>
-          <a:prstGeom prst="rect">
-            <a:avLst/>
-          </a:prstGeom>
-          <a:noFill/>
-          <a:ln/>
-        </p:spPr>
-        <p:txBody>
-          <a:bodyPr wrap="square" lIns="0" tIns="0" rIns="0" bIns="0" rtlCol="0" anchor="t"/>
-          <a:lstStyle/>
+              <a:rPr lang="en-US" sz="980" dirty="0">
+                <a:solidFill>
+                  <a:srgbClr val="10233A"/>
+                </a:solidFill>
+                <a:latin typeface="Avenir Next" pitchFamily="34" charset="0"/>
+                <a:ea typeface="Avenir Next" pitchFamily="34" charset="-122"/>
+                <a:cs typeface="Avenir Next" pitchFamily="34" charset="-120"/>
+              </a:rPr>
+              <a:t>[Pass signal 1]</a:t>
+            </a:r>
+            <a:endParaRPr lang="en-US" sz="980" dirty="0"/>
+          </a:p>
           <a:p>
             <a:pPr marL="152400" indent="-152400">
               <a:buSzPct val="100000"/>
@@ -11794,7 +11296,7 @@
                 <a:ea typeface="Avenir Next" pitchFamily="34" charset="-122"/>
                 <a:cs typeface="Avenir Next" pitchFamily="34" charset="-120"/>
               </a:rPr>
-              <a:t>The narrower fitted resonance tracks the readout resonator consistently.</a:t>
+              <a:t>[Pass signal 2]</a:t>
             </a:r>
             <a:endParaRPr lang="en-US" sz="980" dirty="0"/>
           </a:p>
@@ -11812,25 +11314,7 @@
                 <a:ea typeface="Avenir Next" pitchFamily="34" charset="-122"/>
                 <a:cs typeface="Avenir Next" pitchFamily="34" charset="-120"/>
               </a:rPr>
-              <a:t>Resonance motion follows electrical length intuition.</a:t>
-            </a:r>
-            <a:endParaRPr lang="en-US" sz="980" dirty="0"/>
-          </a:p>
-          <a:p>
-            <a:pPr marL="152400" indent="-152400">
-              <a:buSzPct val="100000"/>
-              <a:buChar char="•"/>
-            </a:pPr>
-            <a:r>
-              <a:rPr lang="en-US" sz="980" dirty="0">
-                <a:solidFill>
-                  <a:srgbClr val="10233A"/>
-                </a:solidFill>
-                <a:latin typeface="Avenir Next" pitchFamily="34" charset="0"/>
-                <a:ea typeface="Avenir Next" pitchFamily="34" charset="-122"/>
-                <a:cs typeface="Avenir Next" pitchFamily="34" charset="-120"/>
-              </a:rPr>
-              <a:t>The resonator disappears from qubit behavior when the qubit interface is opened.</a:t>
+              <a:t>[Pass signal 3]</a:t>
             </a:r>
             <a:endParaRPr lang="en-US" sz="980" dirty="0"/>
           </a:p>
@@ -11925,7 +11409,7 @@
                 <a:ea typeface="Avenir Next" pitchFamily="34" charset="-122"/>
                 <a:cs typeface="Avenir Next" pitchFamily="34" charset="-120"/>
               </a:rPr>
-              <a:t>Actual behavior / plot slot</a:t>
+              <a:t>[Plot / notes area]</a:t>
             </a:r>
             <a:endParaRPr lang="en-US" sz="1100" dirty="0"/>
           </a:p>
@@ -11964,7 +11448,7 @@
                 <a:ea typeface="Avenir Next" pitchFamily="34" charset="-122"/>
                 <a:cs typeface="Avenir Next" pitchFamily="34" charset="-120"/>
               </a:rPr>
-              <a:t>Insert: qwr length sweep on S21 and fitted resonance markers with c_rq toggled on/off.</a:t>
+              <a:t>Paste plot, table, or notes here.</a:t>
             </a:r>
             <a:endParaRPr lang="en-US" sz="1020" dirty="0"/>
           </a:p>
@@ -12003,7 +11487,7 @@
                 <a:ea typeface="Avenir Next" pitchFamily="34" charset="-122"/>
                 <a:cs typeface="Avenir Next" pitchFamily="34" charset="-120"/>
               </a:rPr>
-              <a:t>Recommended inserts</a:t>
+              <a:t>[Optional checklist]</a:t>
             </a:r>
             <a:endParaRPr lang="en-US" sz="970" dirty="0"/>
           </a:p>
@@ -12043,7 +11527,7 @@
                 <a:ea typeface="Avenir Next" pitchFamily="34" charset="-122"/>
                 <a:cs typeface="Avenir Next" pitchFamily="34" charset="-120"/>
               </a:rPr>
-              <a:t>One sweep plot with a monotonic knob on the x-axis</a:t>
+              <a:t>[Add visual 1]</a:t>
             </a:r>
             <a:endParaRPr lang="en-US" sz="950" dirty="0"/>
           </a:p>
@@ -12061,7 +11545,7 @@
                 <a:ea typeface="Avenir Next" pitchFamily="34" charset="-122"/>
                 <a:cs typeface="Avenir Next" pitchFamily="34" charset="-120"/>
               </a:rPr>
-              <a:t>One null-test or decoupling-limit comparison</a:t>
+              <a:t>[Add visual 2]</a:t>
             </a:r>
             <a:endParaRPr lang="en-US" sz="950" dirty="0"/>
           </a:p>
@@ -12079,48 +11563,9 @@
                 <a:ea typeface="Avenir Next" pitchFamily="34" charset="-122"/>
                 <a:cs typeface="Avenir Next" pitchFamily="34" charset="-120"/>
               </a:rPr>
-              <a:t>One sentence on whether the observed trend matches expectation</a:t>
+              <a:t>[Add short takeaway]</a:t>
             </a:r>
             <a:endParaRPr lang="en-US" sz="950" dirty="0"/>
-          </a:p>
-        </p:txBody>
-      </p:sp>
-      <p:sp>
-        <p:nvSpPr>
-          <p:cNvPr id="24" name="Text 22"/>
-          <p:cNvSpPr/>
-          <p:nvPr/>
-        </p:nvSpPr>
-        <p:spPr>
-          <a:xfrm>
-            <a:off x="749808" y="6473952"/>
-            <a:ext cx="5943600" cy="109728"/>
-          </a:xfrm>
-          <a:prstGeom prst="rect">
-            <a:avLst/>
-          </a:prstGeom>
-          <a:noFill/>
-          <a:ln/>
-        </p:spPr>
-        <p:txBody>
-          <a:bodyPr wrap="square" lIns="0" tIns="0" rIns="0" bIns="0" rtlCol="0" anchor="ctr"/>
-          <a:lstStyle/>
-          <a:p>
-            <a:pPr indent="0" marL="0">
-              <a:buNone/>
-            </a:pPr>
-            <a:r>
-              <a:rPr lang="en-US" sz="870" dirty="0">
-                <a:solidFill>
-                  <a:srgbClr val="667487"/>
-                </a:solidFill>
-                <a:latin typeface="Avenir Next" pitchFamily="34" charset="0"/>
-                <a:ea typeface="Avenir Next" pitchFamily="34" charset="-122"/>
-                <a:cs typeface="Avenir Next" pitchFamily="34" charset="-120"/>
-              </a:rPr>
-              <a:t>Front section: first explain the structure, then explain what the structure should do when its own knobs are swept.</a:t>
-            </a:r>
-            <a:endParaRPr lang="en-US" sz="870" dirty="0"/>
           </a:p>
         </p:txBody>
       </p:sp>
@@ -12333,7 +11778,7 @@
                 <a:ea typeface="Avenir Next" pitchFamily="34" charset="-122"/>
                 <a:cs typeface="Avenir Next" pitchFamily="34" charset="-120"/>
               </a:rPr>
-              <a:t>Important modeling fact: in this study the XY lane is represented as a terminated XY node plus the qubit-to-XY coupling capacitors, not as a long distributed geometry block.</a:t>
+              <a:t>[Add one-line framing for this structure.]</a:t>
             </a:r>
             <a:endParaRPr lang="en-US" sz="1100" dirty="0"/>
           </a:p>
@@ -12438,7 +11883,7 @@
                 <a:ea typeface="Menlo" pitchFamily="34" charset="-122"/>
                 <a:cs typeface="Menlo" pitchFamily="34" charset="-120"/>
               </a:rPr>
-              <a:t>c_xy1_f, c_xy2_f</a:t>
+              <a:t>[Parameter 1]</a:t>
             </a:r>
             <a:endParaRPr lang="en-US" sz="920" dirty="0"/>
           </a:p>
@@ -12455,7 +11900,7 @@
                 <a:ea typeface="Menlo" pitchFamily="34" charset="-122"/>
                 <a:cs typeface="Menlo" pitchFamily="34" charset="-120"/>
               </a:rPr>
-              <a:t>xy_port_res_ohm</a:t>
+              <a:t>[Parameter 2]</a:t>
             </a:r>
             <a:endParaRPr lang="en-US" sz="920" dirty="0"/>
           </a:p>
@@ -12472,24 +11917,7 @@
                 <a:ea typeface="Menlo" pitchFamily="34" charset="-122"/>
                 <a:cs typeface="Menlo" pitchFamily="34" charset="-120"/>
               </a:rPr>
-              <a:t>common RLGC only matters indirectly here</a:t>
-            </a:r>
-            <a:endParaRPr lang="en-US" sz="920" dirty="0"/>
-          </a:p>
-          <a:p>
-            <a:pPr indent="0" marL="0">
-              <a:buNone/>
-            </a:pPr>
-            <a:r>
-              <a:rPr lang="en-US" sz="920" dirty="0">
-                <a:solidFill>
-                  <a:srgbClr val="667487"/>
-                </a:solidFill>
-                <a:latin typeface="Menlo" pitchFamily="34" charset="0"/>
-                <a:ea typeface="Menlo" pitchFamily="34" charset="-122"/>
-                <a:cs typeface="Menlo" pitchFamily="34" charset="-120"/>
-              </a:rPr>
-              <a:t>No independent XY length parameter in this model</a:t>
+              <a:t>[Parameter 3]</a:t>
             </a:r>
             <a:endParaRPr lang="en-US" sz="920" dirty="0"/>
           </a:p>
@@ -12594,7 +12022,7 @@
                 <a:ea typeface="Avenir Next" pitchFamily="34" charset="-122"/>
                 <a:cs typeface="Avenir Next" pitchFamily="34" charset="-120"/>
               </a:rPr>
-              <a:t>Primary observable: port-3 loading in the full Y(ω) and its effect on reduced Ydm,in(ω).</a:t>
+              <a:t>[Add primary matrix / observable for this structure.]</a:t>
             </a:r>
             <a:endParaRPr lang="en-US" sz="1010" dirty="0"/>
           </a:p>
@@ -12700,7 +12128,7 @@
                 <a:ea typeface="Avenir Next" pitchFamily="34" charset="-122"/>
                 <a:cs typeface="Avenir Next" pitchFamily="34" charset="-120"/>
               </a:rPr>
-              <a:t>Increasing c_xy should strengthen the XY-only loading contribution.</a:t>
+              <a:t>[Expected response 1]</a:t>
             </a:r>
             <a:endParaRPr lang="en-US" sz="990" dirty="0"/>
           </a:p>
@@ -12718,7 +12146,7 @@
                 <a:ea typeface="Avenir Next" pitchFamily="34" charset="-122"/>
                 <a:cs typeface="Avenir Next" pitchFamily="34" charset="-120"/>
               </a:rPr>
-              <a:t>Setting c_xy1 = c_xy2 = 0 should collapse the XY contribution cleanly.</a:t>
+              <a:t>[Expected response 2]</a:t>
             </a:r>
             <a:endParaRPr lang="en-US" sz="990" dirty="0"/>
           </a:p>
@@ -12736,89 +12164,89 @@
                 <a:ea typeface="Avenir Next" pitchFamily="34" charset="-122"/>
                 <a:cs typeface="Avenir Next" pitchFamily="34" charset="-120"/>
               </a:rPr>
-              <a:t>Changing xy_port_res_ohm should alter dissipative loading but should not create readout resonances.</a:t>
+              <a:t>[Expected response 3]</a:t>
             </a:r>
             <a:endParaRPr lang="en-US" sz="990" dirty="0"/>
           </a:p>
+        </p:txBody>
+      </p:sp>
+      <p:sp>
+        <p:nvSpPr>
+          <p:cNvPr id="16" name="Text 14"/>
+          <p:cNvSpPr/>
+          <p:nvPr/>
+        </p:nvSpPr>
+        <p:spPr>
+          <a:xfrm>
+            <a:off x="4370832" y="4114800"/>
+            <a:ext cx="2743200" cy="164592"/>
+          </a:xfrm>
+          <a:prstGeom prst="rect">
+            <a:avLst/>
+          </a:prstGeom>
+          <a:noFill/>
+          <a:ln/>
+        </p:spPr>
+        <p:txBody>
+          <a:bodyPr wrap="square" lIns="0" tIns="0" rIns="0" bIns="0" rtlCol="0" anchor="ctr"/>
+          <a:lstStyle/>
+          <a:p>
+            <a:pPr indent="0" marL="0">
+              <a:buNone/>
+            </a:pPr>
+            <a:r>
+              <a:rPr lang="en-US" sz="1090" b="1" dirty="0">
+                <a:solidFill>
+                  <a:srgbClr val="10233A"/>
+                </a:solidFill>
+                <a:latin typeface="Avenir Next" pitchFamily="34" charset="0"/>
+                <a:ea typeface="Avenir Next" pitchFamily="34" charset="-122"/>
+                <a:cs typeface="Avenir Next" pitchFamily="34" charset="-120"/>
+              </a:rPr>
+              <a:t>What Counts As A Good Sign</a:t>
+            </a:r>
+            <a:endParaRPr lang="en-US" sz="1090" dirty="0"/>
+          </a:p>
+        </p:txBody>
+      </p:sp>
+      <p:sp>
+        <p:nvSpPr>
+          <p:cNvPr id="17" name="Text 15"/>
+          <p:cNvSpPr/>
+          <p:nvPr/>
+        </p:nvSpPr>
+        <p:spPr>
+          <a:xfrm>
+            <a:off x="4315968" y="4425696"/>
+            <a:ext cx="2907792" cy="768096"/>
+          </a:xfrm>
+          <a:prstGeom prst="rect">
+            <a:avLst/>
+          </a:prstGeom>
+          <a:noFill/>
+          <a:ln/>
+        </p:spPr>
+        <p:txBody>
+          <a:bodyPr wrap="square" lIns="0" tIns="0" rIns="0" bIns="0" rtlCol="0" anchor="t"/>
+          <a:lstStyle/>
           <a:p>
             <a:pPr marL="152400" indent="-152400">
               <a:buSzPct val="100000"/>
               <a:buChar char="•"/>
             </a:pPr>
             <a:r>
-              <a:rPr lang="en-US" sz="990" dirty="0">
-                <a:solidFill>
-                  <a:srgbClr val="10233A"/>
-                </a:solidFill>
-                <a:latin typeface="Avenir Next" pitchFamily="34" charset="0"/>
-                <a:ea typeface="Avenir Next" pitchFamily="34" charset="-122"/>
-                <a:cs typeface="Avenir Next" pitchFamily="34" charset="-120"/>
-              </a:rPr>
-              <a:t>Any claim about XY distributed standing-wave motion should be treated carefully because this model does not expose an XY length knob.</a:t>
-            </a:r>
-            <a:endParaRPr lang="en-US" sz="990" dirty="0"/>
-          </a:p>
-        </p:txBody>
-      </p:sp>
-      <p:sp>
-        <p:nvSpPr>
-          <p:cNvPr id="16" name="Text 14"/>
-          <p:cNvSpPr/>
-          <p:nvPr/>
-        </p:nvSpPr>
-        <p:spPr>
-          <a:xfrm>
-            <a:off x="4370832" y="4114800"/>
-            <a:ext cx="2743200" cy="164592"/>
-          </a:xfrm>
-          <a:prstGeom prst="rect">
-            <a:avLst/>
-          </a:prstGeom>
-          <a:noFill/>
-          <a:ln/>
-        </p:spPr>
-        <p:txBody>
-          <a:bodyPr wrap="square" lIns="0" tIns="0" rIns="0" bIns="0" rtlCol="0" anchor="ctr"/>
-          <a:lstStyle/>
-          <a:p>
-            <a:pPr indent="0" marL="0">
-              <a:buNone/>
-            </a:pPr>
-            <a:r>
-              <a:rPr lang="en-US" sz="1090" b="1" dirty="0">
-                <a:solidFill>
-                  <a:srgbClr val="10233A"/>
-                </a:solidFill>
-                <a:latin typeface="Avenir Next" pitchFamily="34" charset="0"/>
-                <a:ea typeface="Avenir Next" pitchFamily="34" charset="-122"/>
-                <a:cs typeface="Avenir Next" pitchFamily="34" charset="-120"/>
-              </a:rPr>
-              <a:t>What Counts As A Good Sign</a:t>
-            </a:r>
-            <a:endParaRPr lang="en-US" sz="1090" dirty="0"/>
-          </a:p>
-        </p:txBody>
-      </p:sp>
-      <p:sp>
-        <p:nvSpPr>
-          <p:cNvPr id="17" name="Text 15"/>
-          <p:cNvSpPr/>
-          <p:nvPr/>
-        </p:nvSpPr>
-        <p:spPr>
-          <a:xfrm>
-            <a:off x="4315968" y="4425696"/>
-            <a:ext cx="2907792" cy="768096"/>
-          </a:xfrm>
-          <a:prstGeom prst="rect">
-            <a:avLst/>
-          </a:prstGeom>
-          <a:noFill/>
-          <a:ln/>
-        </p:spPr>
-        <p:txBody>
-          <a:bodyPr wrap="square" lIns="0" tIns="0" rIns="0" bIns="0" rtlCol="0" anchor="t"/>
-          <a:lstStyle/>
+              <a:rPr lang="en-US" sz="980" dirty="0">
+                <a:solidFill>
+                  <a:srgbClr val="10233A"/>
+                </a:solidFill>
+                <a:latin typeface="Avenir Next" pitchFamily="34" charset="0"/>
+                <a:ea typeface="Avenir Next" pitchFamily="34" charset="-122"/>
+                <a:cs typeface="Avenir Next" pitchFamily="34" charset="-120"/>
+              </a:rPr>
+              <a:t>[Pass signal 1]</a:t>
+            </a:r>
+            <a:endParaRPr lang="en-US" sz="980" dirty="0"/>
+          </a:p>
           <a:p>
             <a:pPr marL="152400" indent="-152400">
               <a:buSzPct val="100000"/>
@@ -12833,7 +12261,7 @@
                 <a:ea typeface="Avenir Next" pitchFamily="34" charset="-122"/>
                 <a:cs typeface="Avenir Next" pitchFamily="34" charset="-120"/>
               </a:rPr>
-              <a:t>XY-only loss vanishes in the zero-coupling limit.</a:t>
+              <a:t>[Pass signal 2]</a:t>
             </a:r>
             <a:endParaRPr lang="en-US" sz="980" dirty="0"/>
           </a:p>
@@ -12851,25 +12279,7 @@
                 <a:ea typeface="Avenir Next" pitchFamily="34" charset="-122"/>
                 <a:cs typeface="Avenir Next" pitchFamily="34" charset="-120"/>
               </a:rPr>
-              <a:t>XY trends are monotonic with c_xy sweeps.</a:t>
-            </a:r>
-            <a:endParaRPr lang="en-US" sz="980" dirty="0"/>
-          </a:p>
-          <a:p>
-            <a:pPr marL="152400" indent="-152400">
-              <a:buSzPct val="100000"/>
-              <a:buChar char="•"/>
-            </a:pPr>
-            <a:r>
-              <a:rPr lang="en-US" sz="980" dirty="0">
-                <a:solidFill>
-                  <a:srgbClr val="10233A"/>
-                </a:solidFill>
-                <a:latin typeface="Avenir Next" pitchFamily="34" charset="0"/>
-                <a:ea typeface="Avenir Next" pitchFamily="34" charset="-122"/>
-                <a:cs typeface="Avenir Next" pitchFamily="34" charset="-120"/>
-              </a:rPr>
-              <a:t>The study narrative stays aligned with what the model actually contains.</a:t>
+              <a:t>[Pass signal 3]</a:t>
             </a:r>
             <a:endParaRPr lang="en-US" sz="980" dirty="0"/>
           </a:p>
@@ -12964,7 +12374,7 @@
                 <a:ea typeface="Avenir Next" pitchFamily="34" charset="-122"/>
                 <a:cs typeface="Avenir Next" pitchFamily="34" charset="-120"/>
               </a:rPr>
-              <a:t>Actual behavior / plot slot</a:t>
+              <a:t>[Plot / notes area]</a:t>
             </a:r>
             <a:endParaRPr lang="en-US" sz="1100" dirty="0"/>
           </a:p>
@@ -13003,7 +12413,7 @@
                 <a:ea typeface="Avenir Next" pitchFamily="34" charset="-122"/>
                 <a:cs typeface="Avenir Next" pitchFamily="34" charset="-120"/>
               </a:rPr>
-              <a:t>Insert: c_xy sweep, xy_port_res sweep, and one note explaining the XY node abstraction.</a:t>
+              <a:t>Paste plot, table, or notes here.</a:t>
             </a:r>
             <a:endParaRPr lang="en-US" sz="1020" dirty="0"/>
           </a:p>
@@ -13042,7 +12452,7 @@
                 <a:ea typeface="Avenir Next" pitchFamily="34" charset="-122"/>
                 <a:cs typeface="Avenir Next" pitchFamily="34" charset="-120"/>
               </a:rPr>
-              <a:t>Recommended inserts</a:t>
+              <a:t>[Optional checklist]</a:t>
             </a:r>
             <a:endParaRPr lang="en-US" sz="970" dirty="0"/>
           </a:p>
@@ -13082,7 +12492,7 @@
                 <a:ea typeface="Avenir Next" pitchFamily="34" charset="-122"/>
                 <a:cs typeface="Avenir Next" pitchFamily="34" charset="-120"/>
               </a:rPr>
-              <a:t>One sweep plot with a monotonic knob on the x-axis</a:t>
+              <a:t>[Add visual 1]</a:t>
             </a:r>
             <a:endParaRPr lang="en-US" sz="950" dirty="0"/>
           </a:p>
@@ -13100,7 +12510,7 @@
                 <a:ea typeface="Avenir Next" pitchFamily="34" charset="-122"/>
                 <a:cs typeface="Avenir Next" pitchFamily="34" charset="-120"/>
               </a:rPr>
-              <a:t>One null-test or decoupling-limit comparison</a:t>
+              <a:t>[Add visual 2]</a:t>
             </a:r>
             <a:endParaRPr lang="en-US" sz="950" dirty="0"/>
           </a:p>
@@ -13118,48 +12528,9 @@
                 <a:ea typeface="Avenir Next" pitchFamily="34" charset="-122"/>
                 <a:cs typeface="Avenir Next" pitchFamily="34" charset="-120"/>
               </a:rPr>
-              <a:t>One sentence on whether the observed trend matches expectation</a:t>
+              <a:t>[Add short takeaway]</a:t>
             </a:r>
             <a:endParaRPr lang="en-US" sz="950" dirty="0"/>
-          </a:p>
-        </p:txBody>
-      </p:sp>
-      <p:sp>
-        <p:nvSpPr>
-          <p:cNvPr id="24" name="Text 22"/>
-          <p:cNvSpPr/>
-          <p:nvPr/>
-        </p:nvSpPr>
-        <p:spPr>
-          <a:xfrm>
-            <a:off x="749808" y="6473952"/>
-            <a:ext cx="5943600" cy="109728"/>
-          </a:xfrm>
-          <a:prstGeom prst="rect">
-            <a:avLst/>
-          </a:prstGeom>
-          <a:noFill/>
-          <a:ln/>
-        </p:spPr>
-        <p:txBody>
-          <a:bodyPr wrap="square" lIns="0" tIns="0" rIns="0" bIns="0" rtlCol="0" anchor="ctr"/>
-          <a:lstStyle/>
-          <a:p>
-            <a:pPr indent="0" marL="0">
-              <a:buNone/>
-            </a:pPr>
-            <a:r>
-              <a:rPr lang="en-US" sz="870" dirty="0">
-                <a:solidFill>
-                  <a:srgbClr val="667487"/>
-                </a:solidFill>
-                <a:latin typeface="Avenir Next" pitchFamily="34" charset="0"/>
-                <a:ea typeface="Avenir Next" pitchFamily="34" charset="-122"/>
-                <a:cs typeface="Avenir Next" pitchFamily="34" charset="-120"/>
-              </a:rPr>
-              <a:t>Front section: first explain the structure, then explain what the structure should do when its own knobs are swept.</a:t>
-            </a:r>
-            <a:endParaRPr lang="en-US" sz="870" dirty="0"/>
           </a:p>
         </p:txBody>
       </p:sp>
@@ -13372,7 +12743,7 @@
                 <a:ea typeface="Avenir Next" pitchFamily="34" charset="-122"/>
                 <a:cs typeface="Avenir Next" pitchFamily="34" charset="-120"/>
               </a:rPr>
-              <a:t>This is the distributed branch from readout input to output, including left line, half-wave Purcell filter, right line, and terminations.</a:t>
+              <a:t>[Add one-line framing for this structure.]</a:t>
             </a:r>
             <a:endParaRPr lang="en-US" sz="1100" dirty="0"/>
           </a:p>
@@ -13477,7 +12848,7 @@
                 <a:ea typeface="Menlo" pitchFamily="34" charset="-122"/>
                 <a:cs typeface="Menlo" pitchFamily="34" charset="-120"/>
               </a:rPr>
-              <a:t>left_readout_length_m, right_readout_length_m</a:t>
+              <a:t>[Parameter 1]</a:t>
             </a:r>
             <a:endParaRPr lang="en-US" sz="920" dirty="0"/>
           </a:p>
@@ -13494,7 +12865,7 @@
                 <a:ea typeface="Menlo" pitchFamily="34" charset="-122"/>
                 <a:cs typeface="Menlo" pitchFamily="34" charset="-120"/>
               </a:rPr>
-              <a:t>purcell_filter_length_m</a:t>
+              <a:t>[Parameter 2]</a:t>
             </a:r>
             <a:endParaRPr lang="en-US" sz="920" dirty="0"/>
           </a:p>
@@ -13511,41 +12882,7 @@
                 <a:ea typeface="Menlo" pitchFamily="34" charset="-122"/>
                 <a:cs typeface="Menlo" pitchFamily="34" charset="-120"/>
               </a:rPr>
-              <a:t>pf_coupling_cap_in_f, pf_coupling_cap_out_f</a:t>
-            </a:r>
-            <a:endParaRPr lang="en-US" sz="920" dirty="0"/>
-          </a:p>
-          <a:p>
-            <a:pPr indent="0" marL="0">
-              <a:buNone/>
-            </a:pPr>
-            <a:r>
-              <a:rPr lang="en-US" sz="920" dirty="0">
-                <a:solidFill>
-                  <a:srgbClr val="667487"/>
-                </a:solidFill>
-                <a:latin typeface="Menlo" pitchFamily="34" charset="0"/>
-                <a:ea typeface="Menlo" pitchFamily="34" charset="-122"/>
-                <a:cs typeface="Menlo" pitchFamily="34" charset="-120"/>
-              </a:rPr>
-              <a:t>readout_port_res_ohm</a:t>
-            </a:r>
-            <a:endParaRPr lang="en-US" sz="920" dirty="0"/>
-          </a:p>
-          <a:p>
-            <a:pPr indent="0" marL="0">
-              <a:buNone/>
-            </a:pPr>
-            <a:r>
-              <a:rPr lang="en-US" sz="920" dirty="0">
-                <a:solidFill>
-                  <a:srgbClr val="667487"/>
-                </a:solidFill>
-                <a:latin typeface="Menlo" pitchFamily="34" charset="0"/>
-                <a:ea typeface="Menlo" pitchFamily="34" charset="-122"/>
-                <a:cs typeface="Menlo" pitchFamily="34" charset="-120"/>
-              </a:rPr>
-              <a:t>left/right/pf target_dz_m</a:t>
+              <a:t>[Parameter 3]</a:t>
             </a:r>
             <a:endParaRPr lang="en-US" sz="920" dirty="0"/>
           </a:p>
@@ -13650,7 +12987,7 @@
                 <a:ea typeface="Avenir Next" pitchFamily="34" charset="-122"/>
                 <a:cs typeface="Avenir Next" pitchFamily="34" charset="-120"/>
               </a:rPr>
-              <a:t>Primary observable: raw readout-line S21, fitted S21 model, and extracted Purcell-filter / readout-resonator resonances.</a:t>
+              <a:t>[Add primary matrix / observable for this structure.]</a:t>
             </a:r>
             <a:endParaRPr lang="en-US" sz="1010" dirty="0"/>
           </a:p>
@@ -13756,7 +13093,7 @@
                 <a:ea typeface="Avenir Next" pitchFamily="34" charset="-122"/>
                 <a:cs typeface="Avenir Next" pitchFamily="34" charset="-120"/>
               </a:rPr>
-              <a:t>Increasing electrical length should move the associated resonances or notches lower.</a:t>
+              <a:t>[Expected response 1]</a:t>
             </a:r>
             <a:endParaRPr lang="en-US" sz="990" dirty="0"/>
           </a:p>
@@ -13774,7 +13111,7 @@
                 <a:ea typeface="Avenir Next" pitchFamily="34" charset="-122"/>
                 <a:cs typeface="Avenir Next" pitchFamily="34" charset="-120"/>
               </a:rPr>
-              <a:t>Changing PF coupling capacitors should alter bandwidth and feature strength.</a:t>
+              <a:t>[Expected response 2]</a:t>
             </a:r>
             <a:endParaRPr lang="en-US" sz="990" dirty="0"/>
           </a:p>
@@ -13792,89 +13129,89 @@
                 <a:ea typeface="Avenir Next" pitchFamily="34" charset="-122"/>
                 <a:cs typeface="Avenir Next" pitchFamily="34" charset="-120"/>
               </a:rPr>
-              <a:t>Port termination changes should alter line response smoothly, not invent extra physics.</a:t>
+              <a:t>[Expected response 3]</a:t>
             </a:r>
             <a:endParaRPr lang="en-US" sz="990" dirty="0"/>
           </a:p>
+        </p:txBody>
+      </p:sp>
+      <p:sp>
+        <p:nvSpPr>
+          <p:cNvPr id="16" name="Text 14"/>
+          <p:cNvSpPr/>
+          <p:nvPr/>
+        </p:nvSpPr>
+        <p:spPr>
+          <a:xfrm>
+            <a:off x="4370832" y="4114800"/>
+            <a:ext cx="2743200" cy="164592"/>
+          </a:xfrm>
+          <a:prstGeom prst="rect">
+            <a:avLst/>
+          </a:prstGeom>
+          <a:noFill/>
+          <a:ln/>
+        </p:spPr>
+        <p:txBody>
+          <a:bodyPr wrap="square" lIns="0" tIns="0" rIns="0" bIns="0" rtlCol="0" anchor="ctr"/>
+          <a:lstStyle/>
+          <a:p>
+            <a:pPr indent="0" marL="0">
+              <a:buNone/>
+            </a:pPr>
+            <a:r>
+              <a:rPr lang="en-US" sz="1090" b="1" dirty="0">
+                <a:solidFill>
+                  <a:srgbClr val="10233A"/>
+                </a:solidFill>
+                <a:latin typeface="Avenir Next" pitchFamily="34" charset="0"/>
+                <a:ea typeface="Avenir Next" pitchFamily="34" charset="-122"/>
+                <a:cs typeface="Avenir Next" pitchFamily="34" charset="-120"/>
+              </a:rPr>
+              <a:t>What Counts As A Good Sign</a:t>
+            </a:r>
+            <a:endParaRPr lang="en-US" sz="1090" dirty="0"/>
+          </a:p>
+        </p:txBody>
+      </p:sp>
+      <p:sp>
+        <p:nvSpPr>
+          <p:cNvPr id="17" name="Text 15"/>
+          <p:cNvSpPr/>
+          <p:nvPr/>
+        </p:nvSpPr>
+        <p:spPr>
+          <a:xfrm>
+            <a:off x="4315968" y="4425696"/>
+            <a:ext cx="2907792" cy="768096"/>
+          </a:xfrm>
+          <a:prstGeom prst="rect">
+            <a:avLst/>
+          </a:prstGeom>
+          <a:noFill/>
+          <a:ln/>
+        </p:spPr>
+        <p:txBody>
+          <a:bodyPr wrap="square" lIns="0" tIns="0" rIns="0" bIns="0" rtlCol="0" anchor="t"/>
+          <a:lstStyle/>
           <a:p>
             <a:pPr marL="152400" indent="-152400">
               <a:buSzPct val="100000"/>
               <a:buChar char="•"/>
             </a:pPr>
             <a:r>
-              <a:rPr lang="en-US" sz="990" dirty="0">
-                <a:solidFill>
-                  <a:srgbClr val="10233A"/>
-                </a:solidFill>
-                <a:latin typeface="Avenir Next" pitchFamily="34" charset="0"/>
-                <a:ea typeface="Avenir Next" pitchFamily="34" charset="-122"/>
-                <a:cs typeface="Avenir Next" pitchFamily="34" charset="-120"/>
-              </a:rPr>
-              <a:t>Discretization refinement should stabilize S21 features and fitted poles.</a:t>
-            </a:r>
-            <a:endParaRPr lang="en-US" sz="990" dirty="0"/>
-          </a:p>
-        </p:txBody>
-      </p:sp>
-      <p:sp>
-        <p:nvSpPr>
-          <p:cNvPr id="16" name="Text 14"/>
-          <p:cNvSpPr/>
-          <p:nvPr/>
-        </p:nvSpPr>
-        <p:spPr>
-          <a:xfrm>
-            <a:off x="4370832" y="4114800"/>
-            <a:ext cx="2743200" cy="164592"/>
-          </a:xfrm>
-          <a:prstGeom prst="rect">
-            <a:avLst/>
-          </a:prstGeom>
-          <a:noFill/>
-          <a:ln/>
-        </p:spPr>
-        <p:txBody>
-          <a:bodyPr wrap="square" lIns="0" tIns="0" rIns="0" bIns="0" rtlCol="0" anchor="ctr"/>
-          <a:lstStyle/>
-          <a:p>
-            <a:pPr indent="0" marL="0">
-              <a:buNone/>
-            </a:pPr>
-            <a:r>
-              <a:rPr lang="en-US" sz="1090" b="1" dirty="0">
-                <a:solidFill>
-                  <a:srgbClr val="10233A"/>
-                </a:solidFill>
-                <a:latin typeface="Avenir Next" pitchFamily="34" charset="0"/>
-                <a:ea typeface="Avenir Next" pitchFamily="34" charset="-122"/>
-                <a:cs typeface="Avenir Next" pitchFamily="34" charset="-120"/>
-              </a:rPr>
-              <a:t>What Counts As A Good Sign</a:t>
-            </a:r>
-            <a:endParaRPr lang="en-US" sz="1090" dirty="0"/>
-          </a:p>
-        </p:txBody>
-      </p:sp>
-      <p:sp>
-        <p:nvSpPr>
-          <p:cNvPr id="17" name="Text 15"/>
-          <p:cNvSpPr/>
-          <p:nvPr/>
-        </p:nvSpPr>
-        <p:spPr>
-          <a:xfrm>
-            <a:off x="4315968" y="4425696"/>
-            <a:ext cx="2907792" cy="768096"/>
-          </a:xfrm>
-          <a:prstGeom prst="rect">
-            <a:avLst/>
-          </a:prstGeom>
-          <a:noFill/>
-          <a:ln/>
-        </p:spPr>
-        <p:txBody>
-          <a:bodyPr wrap="square" lIns="0" tIns="0" rIns="0" bIns="0" rtlCol="0" anchor="t"/>
-          <a:lstStyle/>
+              <a:rPr lang="en-US" sz="980" dirty="0">
+                <a:solidFill>
+                  <a:srgbClr val="10233A"/>
+                </a:solidFill>
+                <a:latin typeface="Avenir Next" pitchFamily="34" charset="0"/>
+                <a:ea typeface="Avenir Next" pitchFamily="34" charset="-122"/>
+                <a:cs typeface="Avenir Next" pitchFamily="34" charset="-120"/>
+              </a:rPr>
+              <a:t>[Pass signal 1]</a:t>
+            </a:r>
+            <a:endParaRPr lang="en-US" sz="980" dirty="0"/>
+          </a:p>
           <a:p>
             <a:pPr marL="152400" indent="-152400">
               <a:buSzPct val="100000"/>
@@ -13889,7 +13226,7 @@
                 <a:ea typeface="Avenir Next" pitchFamily="34" charset="-122"/>
                 <a:cs typeface="Avenir Next" pitchFamily="34" charset="-120"/>
               </a:rPr>
-              <a:t>The broader fitted feature tracks the Purcell-filter mode consistently.</a:t>
+              <a:t>[Pass signal 2]</a:t>
             </a:r>
             <a:endParaRPr lang="en-US" sz="980" dirty="0"/>
           </a:p>
@@ -13907,25 +13244,7 @@
                 <a:ea typeface="Avenir Next" pitchFamily="34" charset="-122"/>
                 <a:cs typeface="Avenir Next" pitchFamily="34" charset="-120"/>
               </a:rPr>
-              <a:t>Mode motion is consistent with length scaling and coupling strength.</a:t>
-            </a:r>
-            <a:endParaRPr lang="en-US" sz="980" dirty="0"/>
-          </a:p>
-          <a:p>
-            <a:pPr marL="152400" indent="-152400">
-              <a:buSzPct val="100000"/>
-              <a:buChar char="•"/>
-            </a:pPr>
-            <a:r>
-              <a:rPr lang="en-US" sz="980" dirty="0">
-                <a:solidFill>
-                  <a:srgbClr val="10233A"/>
-                </a:solidFill>
-                <a:latin typeface="Avenir Next" pitchFamily="34" charset="0"/>
-                <a:ea typeface="Avenir Next" pitchFamily="34" charset="-122"/>
-                <a:cs typeface="Avenir Next" pitchFamily="34" charset="-120"/>
-              </a:rPr>
-              <a:t>The branch can be characterized cleanly even when qubit couplings are disabled.</a:t>
+              <a:t>[Pass signal 3]</a:t>
             </a:r>
             <a:endParaRPr lang="en-US" sz="980" dirty="0"/>
           </a:p>
@@ -14020,7 +13339,7 @@
                 <a:ea typeface="Avenir Next" pitchFamily="34" charset="-122"/>
                 <a:cs typeface="Avenir Next" pitchFamily="34" charset="-120"/>
               </a:rPr>
-              <a:t>Actual behavior / plot slot</a:t>
+              <a:t>[Plot / notes area]</a:t>
             </a:r>
             <a:endParaRPr lang="en-US" sz="1100" dirty="0"/>
           </a:p>
@@ -14059,7 +13378,7 @@
                 <a:ea typeface="Avenir Next" pitchFamily="34" charset="-122"/>
                 <a:cs typeface="Avenir Next" pitchFamily="34" charset="-120"/>
               </a:rPr>
-              <a:t>Insert: S21 sweeps versus PF length and coupling-cap sweeps, plus vector-fitting overlays.</a:t>
+              <a:t>Paste plot, table, or notes here.</a:t>
             </a:r>
             <a:endParaRPr lang="en-US" sz="1020" dirty="0"/>
           </a:p>
@@ -14098,7 +13417,7 @@
                 <a:ea typeface="Avenir Next" pitchFamily="34" charset="-122"/>
                 <a:cs typeface="Avenir Next" pitchFamily="34" charset="-120"/>
               </a:rPr>
-              <a:t>Recommended inserts</a:t>
+              <a:t>[Optional checklist]</a:t>
             </a:r>
             <a:endParaRPr lang="en-US" sz="970" dirty="0"/>
           </a:p>
@@ -14138,7 +13457,7 @@
                 <a:ea typeface="Avenir Next" pitchFamily="34" charset="-122"/>
                 <a:cs typeface="Avenir Next" pitchFamily="34" charset="-120"/>
               </a:rPr>
-              <a:t>One sweep plot with a monotonic knob on the x-axis</a:t>
+              <a:t>[Add visual 1]</a:t>
             </a:r>
             <a:endParaRPr lang="en-US" sz="950" dirty="0"/>
           </a:p>
@@ -14156,7 +13475,7 @@
                 <a:ea typeface="Avenir Next" pitchFamily="34" charset="-122"/>
                 <a:cs typeface="Avenir Next" pitchFamily="34" charset="-120"/>
               </a:rPr>
-              <a:t>One null-test or decoupling-limit comparison</a:t>
+              <a:t>[Add visual 2]</a:t>
             </a:r>
             <a:endParaRPr lang="en-US" sz="950" dirty="0"/>
           </a:p>
@@ -14174,48 +13493,9 @@
                 <a:ea typeface="Avenir Next" pitchFamily="34" charset="-122"/>
                 <a:cs typeface="Avenir Next" pitchFamily="34" charset="-120"/>
               </a:rPr>
-              <a:t>One sentence on whether the observed trend matches expectation</a:t>
+              <a:t>[Add short takeaway]</a:t>
             </a:r>
             <a:endParaRPr lang="en-US" sz="950" dirty="0"/>
-          </a:p>
-        </p:txBody>
-      </p:sp>
-      <p:sp>
-        <p:nvSpPr>
-          <p:cNvPr id="24" name="Text 22"/>
-          <p:cNvSpPr/>
-          <p:nvPr/>
-        </p:nvSpPr>
-        <p:spPr>
-          <a:xfrm>
-            <a:off x="749808" y="6473952"/>
-            <a:ext cx="5943600" cy="109728"/>
-          </a:xfrm>
-          <a:prstGeom prst="rect">
-            <a:avLst/>
-          </a:prstGeom>
-          <a:noFill/>
-          <a:ln/>
-        </p:spPr>
-        <p:txBody>
-          <a:bodyPr wrap="square" lIns="0" tIns="0" rIns="0" bIns="0" rtlCol="0" anchor="ctr"/>
-          <a:lstStyle/>
-          <a:p>
-            <a:pPr indent="0" marL="0">
-              <a:buNone/>
-            </a:pPr>
-            <a:r>
-              <a:rPr lang="en-US" sz="870" dirty="0">
-                <a:solidFill>
-                  <a:srgbClr val="667487"/>
-                </a:solidFill>
-                <a:latin typeface="Avenir Next" pitchFamily="34" charset="0"/>
-                <a:ea typeface="Avenir Next" pitchFamily="34" charset="-122"/>
-                <a:cs typeface="Avenir Next" pitchFamily="34" charset="-120"/>
-              </a:rPr>
-              <a:t>Front section: first explain the structure, then explain what the structure should do when its own knobs are swept.</a:t>
-            </a:r>
-            <a:endParaRPr lang="en-US" sz="870" dirty="0"/>
           </a:p>
         </p:txBody>
       </p:sp>
@@ -14428,7 +13708,7 @@
                 <a:ea typeface="Avenir Next" pitchFamily="34" charset="-122"/>
                 <a:cs typeface="Avenir Next" pitchFamily="34" charset="-120"/>
               </a:rPr>
-              <a:t>Each pair should be audited by asking whether the parameter-response pattern matches the topology that this model actually contains.</a:t>
+              <a:t>[Add one-line framing for this interface.]</a:t>
             </a:r>
             <a:endParaRPr lang="en-US" sz="1100" dirty="0"/>
           </a:p>
@@ -14599,7 +13879,7 @@
                 <a:ea typeface="Menlo" pitchFamily="34" charset="-122"/>
                 <a:cs typeface="Menlo" pitchFamily="34" charset="-120"/>
               </a:rPr>
-              <a:t>c_xy1_f</a:t>
+              <a:t>[Controlling knob 1]</a:t>
             </a:r>
             <a:endParaRPr lang="en-US" sz="920" dirty="0"/>
           </a:p>
@@ -14616,7 +13896,7 @@
                 <a:ea typeface="Menlo" pitchFamily="34" charset="-122"/>
                 <a:cs typeface="Menlo" pitchFamily="34" charset="-120"/>
               </a:rPr>
-              <a:t>c_xy2_f</a:t>
+              <a:t>[Controlling knob 2]</a:t>
             </a:r>
             <a:endParaRPr lang="en-US" sz="920" dirty="0"/>
           </a:p>
@@ -14633,7 +13913,7 @@
                 <a:ea typeface="Menlo" pitchFamily="34" charset="-122"/>
                 <a:cs typeface="Menlo" pitchFamily="34" charset="-120"/>
               </a:rPr>
-              <a:t>xy_port_res_ohm</a:t>
+              <a:t>[Controlling knob 3]</a:t>
             </a:r>
             <a:endParaRPr lang="en-US" sz="920" dirty="0"/>
           </a:p>
@@ -14738,7 +14018,7 @@
                 <a:ea typeface="Avenir Next" pitchFamily="34" charset="-122"/>
                 <a:cs typeface="Avenir Next" pitchFamily="34" charset="-120"/>
               </a:rPr>
-              <a:t>Use reduced Ydm,in(ω) near qubit resonance plus selected full Y(ω) traces for port 3.</a:t>
+              <a:t>[Add primary matrix / observable for this interface.]</a:t>
             </a:r>
             <a:endParaRPr lang="en-US" sz="1010" dirty="0"/>
           </a:p>
@@ -14844,7 +14124,7 @@
                 <a:ea typeface="Avenir Next" pitchFamily="34" charset="-122"/>
                 <a:cs typeface="Avenir Next" pitchFamily="34" charset="-120"/>
               </a:rPr>
-              <a:t>Increasing c_xy should increase XY-only loading and usually increase Re(Ydm,in).</a:t>
+              <a:t>[Expected behavior 1]</a:t>
             </a:r>
             <a:endParaRPr lang="en-US" sz="990" dirty="0"/>
           </a:p>
@@ -14862,7 +14142,7 @@
                 <a:ea typeface="Avenir Next" pitchFamily="34" charset="-122"/>
                 <a:cs typeface="Avenir Next" pitchFamily="34" charset="-120"/>
               </a:rPr>
-              <a:t>c_xy imbalance changes the centroid weights w1 and w2, so asymmetry should show up systematically.</a:t>
+              <a:t>[Expected behavior 2]</a:t>
             </a:r>
             <a:endParaRPr lang="en-US" sz="990" dirty="0"/>
           </a:p>
@@ -14880,7 +14160,7 @@
                 <a:ea typeface="Avenir Next" pitchFamily="34" charset="-122"/>
                 <a:cs typeface="Avenir Next" pitchFamily="34" charset="-120"/>
               </a:rPr>
-              <a:t>Setting c_xy1 = c_xy2 = 0 should collapse to the no-XY reference.</a:t>
+              <a:t>[Expected behavior 3]</a:t>
             </a:r>
             <a:endParaRPr lang="en-US" sz="990" dirty="0"/>
           </a:p>
@@ -14959,7 +14239,7 @@
                 <a:ea typeface="Avenir Next" pitchFamily="34" charset="-122"/>
                 <a:cs typeface="Avenir Next" pitchFamily="34" charset="-120"/>
               </a:rPr>
-              <a:t>Loss stays large even when c_xy is zero.</a:t>
+              <a:t>[Failure signature 1]</a:t>
             </a:r>
             <a:endParaRPr lang="en-US" sz="980" dirty="0"/>
           </a:p>
@@ -14977,7 +14257,7 @@
                 <a:ea typeface="Avenir Next" pitchFamily="34" charset="-122"/>
                 <a:cs typeface="Avenir Next" pitchFamily="34" charset="-120"/>
               </a:rPr>
-              <a:t>fq moves in the opposite direction with stronger XY loading without another explanation.</a:t>
+              <a:t>[Failure signature 2]</a:t>
             </a:r>
             <a:endParaRPr lang="en-US" sz="980" dirty="0"/>
           </a:p>
@@ -14995,7 +14275,7 @@
                 <a:ea typeface="Avenir Next" pitchFamily="34" charset="-122"/>
                 <a:cs typeface="Avenir Next" pitchFamily="34" charset="-120"/>
               </a:rPr>
-              <a:t>Random extra resonances appear when only c_xy is swept.</a:t>
+              <a:t>[Failure signature 3]</a:t>
             </a:r>
             <a:endParaRPr lang="en-US" sz="980" dirty="0"/>
           </a:p>
@@ -15090,7 +14370,7 @@
                 <a:ea typeface="Avenir Next" pitchFamily="34" charset="-122"/>
                 <a:cs typeface="Avenir Next" pitchFamily="34" charset="-120"/>
               </a:rPr>
-              <a:t>Actual behavior / plot slot</a:t>
+              <a:t>[Plot / notes area]</a:t>
             </a:r>
             <a:endParaRPr lang="en-US" sz="1100" dirty="0"/>
           </a:p>
@@ -15129,7 +14409,7 @@
                 <a:ea typeface="Avenir Next" pitchFamily="34" charset="-122"/>
                 <a:cs typeface="Avenir Next" pitchFamily="34" charset="-120"/>
               </a:rPr>
-              <a:t>Insert: XY-only sweep panel with c_xy magnitude and imbalance variants.</a:t>
+              <a:t>Paste plot, table, or notes here.</a:t>
             </a:r>
             <a:endParaRPr lang="en-US" sz="1020" dirty="0"/>
           </a:p>
@@ -15168,7 +14448,7 @@
                 <a:ea typeface="Avenir Next" pitchFamily="34" charset="-122"/>
                 <a:cs typeface="Avenir Next" pitchFamily="34" charset="-120"/>
               </a:rPr>
-              <a:t>Recommended inserts</a:t>
+              <a:t>[Optional checklist]</a:t>
             </a:r>
             <a:endParaRPr lang="en-US" sz="970" dirty="0"/>
           </a:p>
@@ -15208,7 +14488,7 @@
                 <a:ea typeface="Avenir Next" pitchFamily="34" charset="-122"/>
                 <a:cs typeface="Avenir Next" pitchFamily="34" charset="-120"/>
               </a:rPr>
-              <a:t>One sweep plot with a monotonic knob on the x-axis</a:t>
+              <a:t>[Add visual 1]</a:t>
             </a:r>
             <a:endParaRPr lang="en-US" sz="950" dirty="0"/>
           </a:p>
@@ -15226,7 +14506,7 @@
                 <a:ea typeface="Avenir Next" pitchFamily="34" charset="-122"/>
                 <a:cs typeface="Avenir Next" pitchFamily="34" charset="-120"/>
               </a:rPr>
-              <a:t>One null-test or decoupling-limit comparison</a:t>
+              <a:t>[Add visual 2]</a:t>
             </a:r>
             <a:endParaRPr lang="en-US" sz="950" dirty="0"/>
           </a:p>
@@ -15244,48 +14524,9 @@
                 <a:ea typeface="Avenir Next" pitchFamily="34" charset="-122"/>
                 <a:cs typeface="Avenir Next" pitchFamily="34" charset="-120"/>
               </a:rPr>
-              <a:t>One sentence on whether the observed trend matches expectation</a:t>
+              <a:t>[Add short takeaway]</a:t>
             </a:r>
             <a:endParaRPr lang="en-US" sz="950" dirty="0"/>
-          </a:p>
-        </p:txBody>
-      </p:sp>
-      <p:sp>
-        <p:nvSpPr>
-          <p:cNvPr id="26" name="Text 24"/>
-          <p:cNvSpPr/>
-          <p:nvPr/>
-        </p:nvSpPr>
-        <p:spPr>
-          <a:xfrm>
-            <a:off x="749808" y="6473952"/>
-            <a:ext cx="5943600" cy="109728"/>
-          </a:xfrm>
-          <a:prstGeom prst="rect">
-            <a:avLst/>
-          </a:prstGeom>
-          <a:noFill/>
-          <a:ln/>
-        </p:spPr>
-        <p:txBody>
-          <a:bodyPr wrap="square" lIns="0" tIns="0" rIns="0" bIns="0" rtlCol="0" anchor="ctr"/>
-          <a:lstStyle/>
-          <a:p>
-            <a:pPr indent="0" marL="0">
-              <a:buNone/>
-            </a:pPr>
-            <a:r>
-              <a:rPr lang="en-US" sz="870" dirty="0">
-                <a:solidFill>
-                  <a:srgbClr val="667487"/>
-                </a:solidFill>
-                <a:latin typeface="Avenir Next" pitchFamily="34" charset="0"/>
-                <a:ea typeface="Avenir Next" pitchFamily="34" charset="-122"/>
-                <a:cs typeface="Avenir Next" pitchFamily="34" charset="-120"/>
-              </a:rPr>
-              <a:t>For mediated pairs, path-breaking null tests matter more than large parameter sweeps.</a:t>
-            </a:r>
-            <a:endParaRPr lang="en-US" sz="870" dirty="0"/>
           </a:p>
         </p:txBody>
       </p:sp>

</xml_diff>